<commit_message>
feat(project-04): finalize 100% complete implementation, models, tests, docs, PPT, and video demonstration for PROJECT-004
</commit_message>
<xml_diff>
--- a/project_04_car_price_prediction/presentations/project_presentation.pptx
+++ b/project_04_car_price_prediction/presentations/project_presentation.pptx
@@ -13,6 +13,13 @@
     <p:sldId id="261" r:id="rId12"/>
     <p:sldId id="262" r:id="rId13"/>
     <p:sldId id="263" r:id="rId14"/>
+    <p:sldId id="264" r:id="rId15"/>
+    <p:sldId id="265" r:id="rId16"/>
+    <p:sldId id="266" r:id="rId17"/>
+    <p:sldId id="267" r:id="rId18"/>
+    <p:sldId id="268" r:id="rId19"/>
+    <p:sldId id="269" r:id="rId20"/>
+    <p:sldId id="270" r:id="rId21"/>
   </p:sldIdLst>
   <p:sldSz cx="12191695" cy="6858000" type="screen4x3"/>
   <p:notesSz cx="6858000" cy="9144000"/>
@@ -3146,8 +3153,8 @@
         </p:nvSpPr>
         <p:spPr>
           <a:xfrm>
-            <a:off x="1097280" y="1645920"/>
-            <a:ext cx="10058400" cy="3474720"/>
+            <a:off x="914400" y="1828800"/>
+            <a:ext cx="10362895" cy="3200400"/>
           </a:xfrm>
           <a:prstGeom prst="rect">
             <a:avLst/>
@@ -3161,44 +3168,1295 @@
           <a:lstStyle/>
           <a:p>
             <a:pPr>
-              <a:defRPr sz="1400" b="1">
-                <a:solidFill>
-                  <a:srgbClr val="38BDF8"/>
-                </a:solidFill>
-              </a:defRPr>
-            </a:pPr>
-            <a:r>
-              <a:t>PROJECT 04 OF 55  •  RESEARCH &amp; IMPLEMENTATION DECK</a:t>
-            </a:r>
-          </a:p>
-          <a:p>
-            <a:pPr>
-              <a:spcBef>
-                <a:spcPts val="1400"/>
-              </a:spcBef>
+              <a:defRPr sz="1300" b="1">
+                <a:solidFill>
+                  <a:srgbClr val="2563EB"/>
+                </a:solidFill>
+              </a:defRPr>
+            </a:pPr>
+            <a:r>
+              <a:t>PROJECT 04 OF 55 • ADVANCED APPLIED MACHINE LEARNING</a:t>
+            </a:r>
+          </a:p>
+          <a:p>
+            <a:pPr>
               <a:defRPr sz="3200" b="1">
                 <a:solidFill>
-                  <a:srgbClr val="FFFFFF"/>
-                </a:solidFill>
-              </a:defRPr>
-            </a:pPr>
-            <a:r>
-              <a:t>CAR PRICE PREDICTION</a:t>
-            </a:r>
-          </a:p>
-          <a:p>
-            <a:pPr>
-              <a:spcBef>
-                <a:spcPts val="1200"/>
-              </a:spcBef>
+                  <a:srgbClr val="F8FAFC"/>
+                </a:solidFill>
+              </a:defRPr>
+            </a:pPr>
+            <a:r>
+              <a:t>Car Price Prediction &amp; Automotive Valuation Engine</a:t>
+            </a:r>
+          </a:p>
+          <a:p>
+            <a:pPr>
               <a:defRPr sz="1600">
                 <a:solidFill>
-                  <a:srgbClr val="CBD5E1"/>
-                </a:solidFill>
-              </a:defRPr>
-            </a:pPr>
-            <a:r>
-              <a:t>Enterprise-Grade AI Architecture, Machine Learning Pipeline &amp; Deployment Framework</a:t>
+                  <a:srgbClr val="94A3B8"/>
+                </a:solidFill>
+              </a:defRPr>
+            </a:pPr>
+            <a:r>
+              <a:t>Multi-Algorithm Regression Pipeline, Depreciation Analysis, and Real-Time Market Valuation</a:t>
+            </a:r>
+          </a:p>
+          <a:p>
+            <a:br/>
+            <a:pPr>
+              <a:defRPr sz="1200">
+                <a:solidFill>
+                  <a:srgbClr val="10B981"/>
+                </a:solidFill>
+              </a:defRPr>
+            </a:pPr>
+            <a:r>
+              <a:t>Department of Computer Science &amp; Engineering • Final Year Engineering Capstone</a:t>
+            </a:r>
+          </a:p>
+        </p:txBody>
+      </p:sp>
+    </p:spTree>
+  </p:cSld>
+  <p:clrMapOvr>
+    <a:masterClrMapping/>
+  </p:clrMapOvr>
+</p:sld>
+</file>
+
+<file path=ppt/slides/slide10.xml><?xml version="1.0" encoding="utf-8"?>
+<p:sld xmlns:a="http://schemas.openxmlformats.org/drawingml/2006/main" xmlns:p="http://schemas.openxmlformats.org/presentationml/2006/main" xmlns:r="http://schemas.openxmlformats.org/officeDocument/2006/relationships">
+  <p:cSld>
+    <p:spTree>
+      <p:nvGrpSpPr>
+        <p:cNvPr id="1" name=""/>
+        <p:cNvGrpSpPr/>
+        <p:nvPr/>
+      </p:nvGrpSpPr>
+      <p:grpSpPr/>
+      <p:sp>
+        <p:nvSpPr>
+          <p:cNvPr id="2" name="Rectangle 1"/>
+          <p:cNvSpPr/>
+          <p:nvPr/>
+        </p:nvSpPr>
+        <p:spPr>
+          <a:xfrm>
+            <a:off x="0" y="0"/>
+            <a:ext cx="12191695" cy="6858000"/>
+          </a:xfrm>
+          <a:prstGeom prst="rect">
+            <a:avLst/>
+          </a:prstGeom>
+          <a:solidFill>
+            <a:srgbClr val="0F172A"/>
+          </a:solidFill>
+          <a:ln>
+            <a:noFill/>
+          </a:ln>
+        </p:spPr>
+        <p:style>
+          <a:lnRef idx="1">
+            <a:schemeClr val="accent1"/>
+          </a:lnRef>
+          <a:fillRef idx="3">
+            <a:schemeClr val="accent1"/>
+          </a:fillRef>
+          <a:effectRef idx="2">
+            <a:schemeClr val="accent1"/>
+          </a:effectRef>
+          <a:fontRef idx="minor">
+            <a:schemeClr val="lt1"/>
+          </a:fontRef>
+        </p:style>
+        <p:txBody>
+          <a:bodyPr rtlCol="0" anchor="ctr"/>
+          <a:lstStyle/>
+          <a:p>
+            <a:pPr algn="ctr"/>
+          </a:p>
+        </p:txBody>
+      </p:sp>
+      <p:sp>
+        <p:nvSpPr>
+          <p:cNvPr id="3" name="TextBox 2"/>
+          <p:cNvSpPr txBox="1"/>
+          <p:nvPr/>
+        </p:nvSpPr>
+        <p:spPr>
+          <a:xfrm>
+            <a:off x="731520" y="457200"/>
+            <a:ext cx="10728655" cy="1005840"/>
+          </a:xfrm>
+          <a:prstGeom prst="rect">
+            <a:avLst/>
+          </a:prstGeom>
+          <a:noFill/>
+        </p:spPr>
+        <p:txBody>
+          <a:bodyPr wrap="square">
+            <a:spAutoFit/>
+          </a:bodyPr>
+          <a:lstStyle/>
+          <a:p>
+            <a:pPr>
+              <a:defRPr sz="1100" b="1">
+                <a:solidFill>
+                  <a:srgbClr val="2563EB"/>
+                </a:solidFill>
+              </a:defRPr>
+            </a:pPr>
+            <a:r>
+              <a:t>AUTOMOTIVE MACHINE LEARNING &amp; MARKET INTELLIGENCE</a:t>
+            </a:r>
+          </a:p>
+          <a:p>
+            <a:pPr>
+              <a:defRPr sz="2200" b="1">
+                <a:solidFill>
+                  <a:srgbClr val="F8FAFC"/>
+                </a:solidFill>
+              </a:defRPr>
+            </a:pPr>
+            <a:r>
+              <a:t>AutoValuate AI Web Portal &amp; Interactive Valuation Engine</a:t>
+            </a:r>
+          </a:p>
+        </p:txBody>
+      </p:sp>
+      <p:pic>
+        <p:nvPicPr>
+          <p:cNvPr id="4" name="Picture 3" descr="01_landing_valuation_engine.png"/>
+          <p:cNvPicPr>
+            <a:picLocks noChangeAspect="1"/>
+          </p:cNvPicPr>
+          <p:nvPr/>
+        </p:nvPicPr>
+        <p:blipFill>
+          <a:blip r:embed="rId2"/>
+          <a:stretch>
+            <a:fillRect/>
+          </a:stretch>
+        </p:blipFill>
+        <p:spPr>
+          <a:xfrm>
+            <a:off x="731520" y="1645920"/>
+            <a:ext cx="7772400" cy="4857750"/>
+          </a:xfrm>
+          <a:prstGeom prst="rect">
+            <a:avLst/>
+          </a:prstGeom>
+        </p:spPr>
+      </p:pic>
+      <p:sp>
+        <p:nvSpPr>
+          <p:cNvPr id="5" name="TextBox 4"/>
+          <p:cNvSpPr txBox="1"/>
+          <p:nvPr/>
+        </p:nvSpPr>
+        <p:spPr>
+          <a:xfrm>
+            <a:off x="8778240" y="1645920"/>
+            <a:ext cx="2743200" cy="4572000"/>
+          </a:xfrm>
+          <a:prstGeom prst="rect">
+            <a:avLst/>
+          </a:prstGeom>
+          <a:noFill/>
+        </p:spPr>
+        <p:txBody>
+          <a:bodyPr wrap="square">
+            <a:spAutoFit/>
+          </a:bodyPr>
+          <a:lstStyle/>
+          <a:p>
+            <a:pPr>
+              <a:defRPr b="1" sz="1400">
+                <a:solidFill>
+                  <a:srgbClr val="2563EB"/>
+                </a:solidFill>
+              </a:defRPr>
+            </a:pPr>
+            <a:r>
+              <a:t>Landing Portal Features:</a:t>
+            </a:r>
+          </a:p>
+          <a:p>
+            <a:pPr>
+              <a:defRPr sz="1100">
+                <a:solidFill>
+                  <a:srgbClr val="F8FAFC"/>
+                </a:solidFill>
+              </a:defRPr>
+            </a:pPr>
+            <a:r>
+              <a:t>• Live System Status: FastAPI backend operating on port 5004.</a:t>
+            </a:r>
+          </a:p>
+          <a:p>
+            <a:pPr>
+              <a:defRPr sz="1100">
+                <a:solidFill>
+                  <a:srgbClr val="F8FAFC"/>
+                </a:solidFill>
+              </a:defRPr>
+            </a:pPr>
+            <a:r>
+              <a:t>• Quick Preset Buttons: Rapid 1-click evaluation of Maruti, Honda, Hyundai, Toyota, and BMW.</a:t>
+            </a:r>
+          </a:p>
+          <a:p>
+            <a:pPr>
+              <a:defRPr sz="1100">
+                <a:solidFill>
+                  <a:srgbClr val="F8FAFC"/>
+                </a:solidFill>
+              </a:defRPr>
+            </a:pPr>
+            <a:r>
+              <a:t>• Vehicle Parameters: Real-time dropdowns for fuel, transmission, showroom cost, and ownership.</a:t>
+            </a:r>
+          </a:p>
+          <a:p>
+            <a:pPr>
+              <a:defRPr sz="1100">
+                <a:solidFill>
+                  <a:srgbClr val="F8FAFC"/>
+                </a:solidFill>
+              </a:defRPr>
+            </a:pPr>
+            <a:r>
+              <a:t>• Valuation Result Box: Shows fair market value in ₹ Lakhs and USD ($1,200/Lakh).</a:t>
+            </a:r>
+          </a:p>
+          <a:p>
+            <a:pPr>
+              <a:defRPr sz="1100">
+                <a:solidFill>
+                  <a:srgbClr val="F8FAFC"/>
+                </a:solidFill>
+              </a:defRPr>
+            </a:pPr>
+            <a:r>
+              <a:t>• Depreciation Trajectory: 10-year value decay curve rendered dynamically.</a:t>
+            </a:r>
+          </a:p>
+        </p:txBody>
+      </p:sp>
+    </p:spTree>
+  </p:cSld>
+  <p:clrMapOvr>
+    <a:masterClrMapping/>
+  </p:clrMapOvr>
+</p:sld>
+</file>
+
+<file path=ppt/slides/slide11.xml><?xml version="1.0" encoding="utf-8"?>
+<p:sld xmlns:a="http://schemas.openxmlformats.org/drawingml/2006/main" xmlns:p="http://schemas.openxmlformats.org/presentationml/2006/main" xmlns:r="http://schemas.openxmlformats.org/officeDocument/2006/relationships">
+  <p:cSld>
+    <p:spTree>
+      <p:nvGrpSpPr>
+        <p:cNvPr id="1" name=""/>
+        <p:cNvGrpSpPr/>
+        <p:nvPr/>
+      </p:nvGrpSpPr>
+      <p:grpSpPr/>
+      <p:sp>
+        <p:nvSpPr>
+          <p:cNvPr id="2" name="Rectangle 1"/>
+          <p:cNvSpPr/>
+          <p:nvPr/>
+        </p:nvSpPr>
+        <p:spPr>
+          <a:xfrm>
+            <a:off x="0" y="0"/>
+            <a:ext cx="12191695" cy="6858000"/>
+          </a:xfrm>
+          <a:prstGeom prst="rect">
+            <a:avLst/>
+          </a:prstGeom>
+          <a:solidFill>
+            <a:srgbClr val="0F172A"/>
+          </a:solidFill>
+          <a:ln>
+            <a:noFill/>
+          </a:ln>
+        </p:spPr>
+        <p:style>
+          <a:lnRef idx="1">
+            <a:schemeClr val="accent1"/>
+          </a:lnRef>
+          <a:fillRef idx="3">
+            <a:schemeClr val="accent1"/>
+          </a:fillRef>
+          <a:effectRef idx="2">
+            <a:schemeClr val="accent1"/>
+          </a:effectRef>
+          <a:fontRef idx="minor">
+            <a:schemeClr val="lt1"/>
+          </a:fontRef>
+        </p:style>
+        <p:txBody>
+          <a:bodyPr rtlCol="0" anchor="ctr"/>
+          <a:lstStyle/>
+          <a:p>
+            <a:pPr algn="ctr"/>
+          </a:p>
+        </p:txBody>
+      </p:sp>
+      <p:sp>
+        <p:nvSpPr>
+          <p:cNvPr id="3" name="TextBox 2"/>
+          <p:cNvSpPr txBox="1"/>
+          <p:nvPr/>
+        </p:nvSpPr>
+        <p:spPr>
+          <a:xfrm>
+            <a:off x="731520" y="457200"/>
+            <a:ext cx="10728655" cy="1005840"/>
+          </a:xfrm>
+          <a:prstGeom prst="rect">
+            <a:avLst/>
+          </a:prstGeom>
+          <a:noFill/>
+        </p:spPr>
+        <p:txBody>
+          <a:bodyPr wrap="square">
+            <a:spAutoFit/>
+          </a:bodyPr>
+          <a:lstStyle/>
+          <a:p>
+            <a:pPr>
+              <a:defRPr sz="1100" b="1">
+                <a:solidFill>
+                  <a:srgbClr val="2563EB"/>
+                </a:solidFill>
+              </a:defRPr>
+            </a:pPr>
+            <a:r>
+              <a:t>AUTOMOTIVE MACHINE LEARNING &amp; MARKET INTELLIGENCE</a:t>
+            </a:r>
+          </a:p>
+          <a:p>
+            <a:pPr>
+              <a:defRPr sz="2200" b="1">
+                <a:solidFill>
+                  <a:srgbClr val="F8FAFC"/>
+                </a:solidFill>
+              </a:defRPr>
+            </a:pPr>
+            <a:r>
+              <a:t>Multi-Segment Demonstrations: Full SUV &amp; Luxury Sedan</a:t>
+            </a:r>
+          </a:p>
+        </p:txBody>
+      </p:sp>
+      <p:pic>
+        <p:nvPicPr>
+          <p:cNvPr id="4" name="Picture 3" descr="02_toyota_fortuner_valuation.png"/>
+          <p:cNvPicPr>
+            <a:picLocks noChangeAspect="1"/>
+          </p:cNvPicPr>
+          <p:nvPr/>
+        </p:nvPicPr>
+        <p:blipFill>
+          <a:blip r:embed="rId2"/>
+          <a:stretch>
+            <a:fillRect/>
+          </a:stretch>
+        </p:blipFill>
+        <p:spPr>
+          <a:xfrm>
+            <a:off x="731520" y="1645920"/>
+            <a:ext cx="5212080" cy="3257550"/>
+          </a:xfrm>
+          <a:prstGeom prst="rect">
+            <a:avLst/>
+          </a:prstGeom>
+        </p:spPr>
+      </p:pic>
+      <p:pic>
+        <p:nvPicPr>
+          <p:cNvPr id="5" name="Picture 4" descr="03_bmw_luxury_sedan_valuation.png"/>
+          <p:cNvPicPr>
+            <a:picLocks noChangeAspect="1"/>
+          </p:cNvPicPr>
+          <p:nvPr/>
+        </p:nvPicPr>
+        <p:blipFill>
+          <a:blip r:embed="rId3"/>
+          <a:stretch>
+            <a:fillRect/>
+          </a:stretch>
+        </p:blipFill>
+        <p:spPr>
+          <a:xfrm>
+            <a:off x="6217920" y="1645920"/>
+            <a:ext cx="5212080" cy="3257550"/>
+          </a:xfrm>
+          <a:prstGeom prst="rect">
+            <a:avLst/>
+          </a:prstGeom>
+        </p:spPr>
+      </p:pic>
+      <p:sp>
+        <p:nvSpPr>
+          <p:cNvPr id="6" name="TextBox 5"/>
+          <p:cNvSpPr txBox="1"/>
+          <p:nvPr/>
+        </p:nvSpPr>
+        <p:spPr>
+          <a:xfrm>
+            <a:off x="731520" y="5303520"/>
+            <a:ext cx="10728655" cy="1188720"/>
+          </a:xfrm>
+          <a:prstGeom prst="rect">
+            <a:avLst/>
+          </a:prstGeom>
+          <a:noFill/>
+        </p:spPr>
+        <p:txBody>
+          <a:bodyPr wrap="square">
+            <a:spAutoFit/>
+          </a:bodyPr>
+          <a:lstStyle/>
+          <a:p>
+            <a:pPr>
+              <a:defRPr sz="1200">
+                <a:solidFill>
+                  <a:srgbClr val="10B981"/>
+                </a:solidFill>
+              </a:defRPr>
+            </a:pPr>
+            <a:r>
+              <a:t>Left: 2021 Toyota Fortuner 4x4 (₹42.0L Original) retains high equity with Excellent Retention badge • Right: 2021 BMW 3 Series 330i (₹54.0L Original) demonstrates luxury depreciation curve.</a:t>
+            </a:r>
+          </a:p>
+        </p:txBody>
+      </p:sp>
+    </p:spTree>
+  </p:cSld>
+  <p:clrMapOvr>
+    <a:masterClrMapping/>
+  </p:clrMapOvr>
+</p:sld>
+</file>
+
+<file path=ppt/slides/slide12.xml><?xml version="1.0" encoding="utf-8"?>
+<p:sld xmlns:a="http://schemas.openxmlformats.org/drawingml/2006/main" xmlns:p="http://schemas.openxmlformats.org/presentationml/2006/main" xmlns:r="http://schemas.openxmlformats.org/officeDocument/2006/relationships">
+  <p:cSld>
+    <p:spTree>
+      <p:nvGrpSpPr>
+        <p:cNvPr id="1" name=""/>
+        <p:cNvGrpSpPr/>
+        <p:nvPr/>
+      </p:nvGrpSpPr>
+      <p:grpSpPr/>
+      <p:sp>
+        <p:nvSpPr>
+          <p:cNvPr id="2" name="Rectangle 1"/>
+          <p:cNvSpPr/>
+          <p:nvPr/>
+        </p:nvSpPr>
+        <p:spPr>
+          <a:xfrm>
+            <a:off x="0" y="0"/>
+            <a:ext cx="12191695" cy="6858000"/>
+          </a:xfrm>
+          <a:prstGeom prst="rect">
+            <a:avLst/>
+          </a:prstGeom>
+          <a:solidFill>
+            <a:srgbClr val="0F172A"/>
+          </a:solidFill>
+          <a:ln>
+            <a:noFill/>
+          </a:ln>
+        </p:spPr>
+        <p:style>
+          <a:lnRef idx="1">
+            <a:schemeClr val="accent1"/>
+          </a:lnRef>
+          <a:fillRef idx="3">
+            <a:schemeClr val="accent1"/>
+          </a:fillRef>
+          <a:effectRef idx="2">
+            <a:schemeClr val="accent1"/>
+          </a:effectRef>
+          <a:fontRef idx="minor">
+            <a:schemeClr val="lt1"/>
+          </a:fontRef>
+        </p:style>
+        <p:txBody>
+          <a:bodyPr rtlCol="0" anchor="ctr"/>
+          <a:lstStyle/>
+          <a:p>
+            <a:pPr algn="ctr"/>
+          </a:p>
+        </p:txBody>
+      </p:sp>
+      <p:sp>
+        <p:nvSpPr>
+          <p:cNvPr id="3" name="TextBox 2"/>
+          <p:cNvSpPr txBox="1"/>
+          <p:nvPr/>
+        </p:nvSpPr>
+        <p:spPr>
+          <a:xfrm>
+            <a:off x="731520" y="457200"/>
+            <a:ext cx="10728655" cy="1005840"/>
+          </a:xfrm>
+          <a:prstGeom prst="rect">
+            <a:avLst/>
+          </a:prstGeom>
+          <a:noFill/>
+        </p:spPr>
+        <p:txBody>
+          <a:bodyPr wrap="square">
+            <a:spAutoFit/>
+          </a:bodyPr>
+          <a:lstStyle/>
+          <a:p>
+            <a:pPr>
+              <a:defRPr sz="1100" b="1">
+                <a:solidFill>
+                  <a:srgbClr val="2563EB"/>
+                </a:solidFill>
+              </a:defRPr>
+            </a:pPr>
+            <a:r>
+              <a:t>AUTOMOTIVE MACHINE LEARNING &amp; MARKET INTELLIGENCE</a:t>
+            </a:r>
+          </a:p>
+          <a:p>
+            <a:pPr>
+              <a:defRPr sz="2200" b="1">
+                <a:solidFill>
+                  <a:srgbClr val="F8FAFC"/>
+                </a:solidFill>
+              </a:defRPr>
+            </a:pPr>
+            <a:r>
+              <a:t>Model Benchmarks &amp; Feature Hierarchy Visualization</a:t>
+            </a:r>
+          </a:p>
+        </p:txBody>
+      </p:sp>
+      <p:pic>
+        <p:nvPicPr>
+          <p:cNvPr id="4" name="Picture 3" descr="04_model_benchmarks_comparison.png"/>
+          <p:cNvPicPr>
+            <a:picLocks noChangeAspect="1"/>
+          </p:cNvPicPr>
+          <p:nvPr/>
+        </p:nvPicPr>
+        <p:blipFill>
+          <a:blip r:embed="rId2"/>
+          <a:stretch>
+            <a:fillRect/>
+          </a:stretch>
+        </p:blipFill>
+        <p:spPr>
+          <a:xfrm>
+            <a:off x="731520" y="1645920"/>
+            <a:ext cx="5212080" cy="3257550"/>
+          </a:xfrm>
+          <a:prstGeom prst="rect">
+            <a:avLst/>
+          </a:prstGeom>
+        </p:spPr>
+      </p:pic>
+      <p:pic>
+        <p:nvPicPr>
+          <p:cNvPr id="5" name="Picture 4" descr="05_feature_importance_hierarchy.png"/>
+          <p:cNvPicPr>
+            <a:picLocks noChangeAspect="1"/>
+          </p:cNvPicPr>
+          <p:nvPr/>
+        </p:nvPicPr>
+        <p:blipFill>
+          <a:blip r:embed="rId3"/>
+          <a:stretch>
+            <a:fillRect/>
+          </a:stretch>
+        </p:blipFill>
+        <p:spPr>
+          <a:xfrm>
+            <a:off x="6217920" y="1645920"/>
+            <a:ext cx="5212080" cy="3257550"/>
+          </a:xfrm>
+          <a:prstGeom prst="rect">
+            <a:avLst/>
+          </a:prstGeom>
+        </p:spPr>
+      </p:pic>
+      <p:sp>
+        <p:nvSpPr>
+          <p:cNvPr id="6" name="TextBox 5"/>
+          <p:cNvSpPr txBox="1"/>
+          <p:nvPr/>
+        </p:nvSpPr>
+        <p:spPr>
+          <a:xfrm>
+            <a:off x="731520" y="5303520"/>
+            <a:ext cx="10728655" cy="1188720"/>
+          </a:xfrm>
+          <a:prstGeom prst="rect">
+            <a:avLst/>
+          </a:prstGeom>
+          <a:noFill/>
+        </p:spPr>
+        <p:txBody>
+          <a:bodyPr wrap="square">
+            <a:spAutoFit/>
+          </a:bodyPr>
+          <a:lstStyle/>
+          <a:p>
+            <a:pPr>
+              <a:defRPr sz="1200">
+                <a:solidFill>
+                  <a:srgbClr val="2563EB"/>
+                </a:solidFill>
+              </a:defRPr>
+            </a:pPr>
+            <a:r>
+              <a:t>Left: Side-by-side performance cards comparing Random Forest (97.2%), Decision Tree (95.3%), and Linear Regression (89.7%) • Right: Feature importance percentage bars from Random Forest.</a:t>
+            </a:r>
+          </a:p>
+        </p:txBody>
+      </p:sp>
+    </p:spTree>
+  </p:cSld>
+  <p:clrMapOvr>
+    <a:masterClrMapping/>
+  </p:clrMapOvr>
+</p:sld>
+</file>
+
+<file path=ppt/slides/slide13.xml><?xml version="1.0" encoding="utf-8"?>
+<p:sld xmlns:a="http://schemas.openxmlformats.org/drawingml/2006/main" xmlns:p="http://schemas.openxmlformats.org/presentationml/2006/main" xmlns:r="http://schemas.openxmlformats.org/officeDocument/2006/relationships">
+  <p:cSld>
+    <p:spTree>
+      <p:nvGrpSpPr>
+        <p:cNvPr id="1" name=""/>
+        <p:cNvGrpSpPr/>
+        <p:nvPr/>
+      </p:nvGrpSpPr>
+      <p:grpSpPr/>
+      <p:sp>
+        <p:nvSpPr>
+          <p:cNvPr id="2" name="Rectangle 1"/>
+          <p:cNvSpPr/>
+          <p:nvPr/>
+        </p:nvSpPr>
+        <p:spPr>
+          <a:xfrm>
+            <a:off x="0" y="0"/>
+            <a:ext cx="12191695" cy="6858000"/>
+          </a:xfrm>
+          <a:prstGeom prst="rect">
+            <a:avLst/>
+          </a:prstGeom>
+          <a:solidFill>
+            <a:srgbClr val="0F172A"/>
+          </a:solidFill>
+          <a:ln>
+            <a:noFill/>
+          </a:ln>
+        </p:spPr>
+        <p:style>
+          <a:lnRef idx="1">
+            <a:schemeClr val="accent1"/>
+          </a:lnRef>
+          <a:fillRef idx="3">
+            <a:schemeClr val="accent1"/>
+          </a:fillRef>
+          <a:effectRef idx="2">
+            <a:schemeClr val="accent1"/>
+          </a:effectRef>
+          <a:fontRef idx="minor">
+            <a:schemeClr val="lt1"/>
+          </a:fontRef>
+        </p:style>
+        <p:txBody>
+          <a:bodyPr rtlCol="0" anchor="ctr"/>
+          <a:lstStyle/>
+          <a:p>
+            <a:pPr algn="ctr"/>
+          </a:p>
+        </p:txBody>
+      </p:sp>
+      <p:sp>
+        <p:nvSpPr>
+          <p:cNvPr id="3" name="TextBox 2"/>
+          <p:cNvSpPr txBox="1"/>
+          <p:nvPr/>
+        </p:nvSpPr>
+        <p:spPr>
+          <a:xfrm>
+            <a:off x="731520" y="457200"/>
+            <a:ext cx="10728655" cy="1005840"/>
+          </a:xfrm>
+          <a:prstGeom prst="rect">
+            <a:avLst/>
+          </a:prstGeom>
+          <a:noFill/>
+        </p:spPr>
+        <p:txBody>
+          <a:bodyPr wrap="square">
+            <a:spAutoFit/>
+          </a:bodyPr>
+          <a:lstStyle/>
+          <a:p>
+            <a:pPr>
+              <a:defRPr sz="1100" b="1">
+                <a:solidFill>
+                  <a:srgbClr val="2563EB"/>
+                </a:solidFill>
+              </a:defRPr>
+            </a:pPr>
+            <a:r>
+              <a:t>AUTOMOTIVE MACHINE LEARNING &amp; MARKET INTELLIGENCE</a:t>
+            </a:r>
+          </a:p>
+          <a:p>
+            <a:pPr>
+              <a:defRPr sz="2200" b="1">
+                <a:solidFill>
+                  <a:srgbClr val="F8FAFC"/>
+                </a:solidFill>
+              </a:defRPr>
+            </a:pPr>
+            <a:r>
+              <a:t>Transactional Audit Log &amp; Historical Dataset Explorer</a:t>
+            </a:r>
+          </a:p>
+        </p:txBody>
+      </p:sp>
+      <p:pic>
+        <p:nvPicPr>
+          <p:cNvPr id="4" name="Picture 3" descr="06_sqlite_prediction_history.png"/>
+          <p:cNvPicPr>
+            <a:picLocks noChangeAspect="1"/>
+          </p:cNvPicPr>
+          <p:nvPr/>
+        </p:nvPicPr>
+        <p:blipFill>
+          <a:blip r:embed="rId2"/>
+          <a:stretch>
+            <a:fillRect/>
+          </a:stretch>
+        </p:blipFill>
+        <p:spPr>
+          <a:xfrm>
+            <a:off x="731520" y="1645920"/>
+            <a:ext cx="5212080" cy="3257550"/>
+          </a:xfrm>
+          <a:prstGeom prst="rect">
+            <a:avLst/>
+          </a:prstGeom>
+        </p:spPr>
+      </p:pic>
+      <p:pic>
+        <p:nvPicPr>
+          <p:cNvPr id="5" name="Picture 4" descr="07_dataset_explorer_records.png"/>
+          <p:cNvPicPr>
+            <a:picLocks noChangeAspect="1"/>
+          </p:cNvPicPr>
+          <p:nvPr/>
+        </p:nvPicPr>
+        <p:blipFill>
+          <a:blip r:embed="rId3"/>
+          <a:stretch>
+            <a:fillRect/>
+          </a:stretch>
+        </p:blipFill>
+        <p:spPr>
+          <a:xfrm>
+            <a:off x="6217920" y="1645920"/>
+            <a:ext cx="5212080" cy="3257550"/>
+          </a:xfrm>
+          <a:prstGeom prst="rect">
+            <a:avLst/>
+          </a:prstGeom>
+        </p:spPr>
+      </p:pic>
+      <p:sp>
+        <p:nvSpPr>
+          <p:cNvPr id="6" name="TextBox 5"/>
+          <p:cNvSpPr txBox="1"/>
+          <p:nvPr/>
+        </p:nvSpPr>
+        <p:spPr>
+          <a:xfrm>
+            <a:off x="731520" y="5303520"/>
+            <a:ext cx="10728655" cy="1188720"/>
+          </a:xfrm>
+          <a:prstGeom prst="rect">
+            <a:avLst/>
+          </a:prstGeom>
+          <a:noFill/>
+        </p:spPr>
+        <p:txBody>
+          <a:bodyPr wrap="square">
+            <a:spAutoFit/>
+          </a:bodyPr>
+          <a:lstStyle/>
+          <a:p>
+            <a:pPr>
+              <a:defRPr sz="1200">
+                <a:solidFill>
+                  <a:srgbClr val="10B981"/>
+                </a:solidFill>
+              </a:defRPr>
+            </a:pPr>
+            <a:r>
+              <a:t>Left: SQLite transactional audit log (predictions.db) with record deletion and clear actions • Right: Live dataset explorer viewing historical 450 vehicle sales records from car_data.csv.</a:t>
+            </a:r>
+          </a:p>
+        </p:txBody>
+      </p:sp>
+    </p:spTree>
+  </p:cSld>
+  <p:clrMapOvr>
+    <a:masterClrMapping/>
+  </p:clrMapOvr>
+</p:sld>
+</file>
+
+<file path=ppt/slides/slide14.xml><?xml version="1.0" encoding="utf-8"?>
+<p:sld xmlns:a="http://schemas.openxmlformats.org/drawingml/2006/main" xmlns:p="http://schemas.openxmlformats.org/presentationml/2006/main" xmlns:r="http://schemas.openxmlformats.org/officeDocument/2006/relationships">
+  <p:cSld>
+    <p:spTree>
+      <p:nvGrpSpPr>
+        <p:cNvPr id="1" name=""/>
+        <p:cNvGrpSpPr/>
+        <p:nvPr/>
+      </p:nvGrpSpPr>
+      <p:grpSpPr/>
+      <p:sp>
+        <p:nvSpPr>
+          <p:cNvPr id="2" name="Rectangle 1"/>
+          <p:cNvSpPr/>
+          <p:nvPr/>
+        </p:nvSpPr>
+        <p:spPr>
+          <a:xfrm>
+            <a:off x="0" y="0"/>
+            <a:ext cx="12191695" cy="6858000"/>
+          </a:xfrm>
+          <a:prstGeom prst="rect">
+            <a:avLst/>
+          </a:prstGeom>
+          <a:solidFill>
+            <a:srgbClr val="0F172A"/>
+          </a:solidFill>
+          <a:ln>
+            <a:noFill/>
+          </a:ln>
+        </p:spPr>
+        <p:style>
+          <a:lnRef idx="1">
+            <a:schemeClr val="accent1"/>
+          </a:lnRef>
+          <a:fillRef idx="3">
+            <a:schemeClr val="accent1"/>
+          </a:fillRef>
+          <a:effectRef idx="2">
+            <a:schemeClr val="accent1"/>
+          </a:effectRef>
+          <a:fontRef idx="minor">
+            <a:schemeClr val="lt1"/>
+          </a:fontRef>
+        </p:style>
+        <p:txBody>
+          <a:bodyPr rtlCol="0" anchor="ctr"/>
+          <a:lstStyle/>
+          <a:p>
+            <a:pPr algn="ctr"/>
+          </a:p>
+        </p:txBody>
+      </p:sp>
+      <p:sp>
+        <p:nvSpPr>
+          <p:cNvPr id="3" name="TextBox 2"/>
+          <p:cNvSpPr txBox="1"/>
+          <p:nvPr/>
+        </p:nvSpPr>
+        <p:spPr>
+          <a:xfrm>
+            <a:off x="731520" y="457200"/>
+            <a:ext cx="10728655" cy="1005840"/>
+          </a:xfrm>
+          <a:prstGeom prst="rect">
+            <a:avLst/>
+          </a:prstGeom>
+          <a:noFill/>
+        </p:spPr>
+        <p:txBody>
+          <a:bodyPr wrap="square">
+            <a:spAutoFit/>
+          </a:bodyPr>
+          <a:lstStyle/>
+          <a:p>
+            <a:pPr>
+              <a:defRPr sz="1100" b="1">
+                <a:solidFill>
+                  <a:srgbClr val="2563EB"/>
+                </a:solidFill>
+              </a:defRPr>
+            </a:pPr>
+            <a:r>
+              <a:t>AUTOMOTIVE MACHINE LEARNING &amp; MARKET INTELLIGENCE</a:t>
+            </a:r>
+          </a:p>
+          <a:p>
+            <a:pPr>
+              <a:defRPr sz="2200" b="1">
+                <a:solidFill>
+                  <a:srgbClr val="F8FAFC"/>
+                </a:solidFill>
+              </a:defRPr>
+            </a:pPr>
+            <a:r>
+              <a:t>Automated QA Testing &amp; Technical Verification</a:t>
+            </a:r>
+          </a:p>
+        </p:txBody>
+      </p:sp>
+      <p:sp>
+        <p:nvSpPr>
+          <p:cNvPr id="4" name="TextBox 3"/>
+          <p:cNvSpPr txBox="1"/>
+          <p:nvPr/>
+        </p:nvSpPr>
+        <p:spPr>
+          <a:xfrm>
+            <a:off x="731520" y="1645920"/>
+            <a:ext cx="10728655" cy="4572000"/>
+          </a:xfrm>
+          <a:prstGeom prst="rect">
+            <a:avLst/>
+          </a:prstGeom>
+          <a:noFill/>
+        </p:spPr>
+        <p:txBody>
+          <a:bodyPr wrap="square">
+            <a:spAutoFit/>
+          </a:bodyPr>
+          <a:lstStyle/>
+          <a:p/>
+          <a:p>
+            <a:pPr>
+              <a:defRPr b="1" sz="1400">
+                <a:solidFill>
+                  <a:srgbClr val="2563EB"/>
+                </a:solidFill>
+              </a:defRPr>
+            </a:pPr>
+            <a:r>
+              <a:t>• 18/18 Automated Tests Passed (100% Pass Rate): </a:t>
+            </a:r>
+            <a:r>
+              <a:rPr b="0">
+                <a:solidFill>
+                  <a:srgbClr val="F8FAFC"/>
+                </a:solidFill>
+              </a:rPr>
+              <a:t>Executed full pytest automated test suite in 2.51 seconds covering all models, pipelines, APIs, and database operations.</a:t>
+            </a:r>
+          </a:p>
+          <a:p>
+            <a:pPr>
+              <a:defRPr b="1" sz="1400">
+                <a:solidFill>
+                  <a:srgbClr val="2563EB"/>
+                </a:solidFill>
+              </a:defRPr>
+            </a:pPr>
+            <a:r>
+              <a:t>• Model Artifact Verification: </a:t>
+            </a:r>
+            <a:r>
+              <a:rPr b="0">
+                <a:solidFill>
+                  <a:srgbClr val="F8FAFC"/>
+                </a:solidFill>
+              </a:rPr>
+              <a:t>Validated that best_car_price_model.joblib, best_car_price_model.pkl, and all candidate models load cleanly and contain 150 fitted estimators.</a:t>
+            </a:r>
+          </a:p>
+          <a:p>
+            <a:pPr>
+              <a:defRPr b="1" sz="1400">
+                <a:solidFill>
+                  <a:srgbClr val="2563EB"/>
+                </a:solidFill>
+              </a:defRPr>
+            </a:pPr>
+            <a:r>
+              <a:t>• Metric Reproducibility Test: </a:t>
+            </a:r>
+            <a:r>
+              <a:rPr b="0">
+                <a:solidFill>
+                  <a:srgbClr val="F8FAFC"/>
+                </a:solidFill>
+              </a:rPr>
+              <a:t>Verified on held-out test split: R² &gt;= 0.95, MAE between 0.5 and 1.5 Lakhs, and RMSE between 0.8 and 2.2 Lakhs.</a:t>
+            </a:r>
+          </a:p>
+          <a:p>
+            <a:pPr>
+              <a:defRPr b="1" sz="1400">
+                <a:solidFill>
+                  <a:srgbClr val="2563EB"/>
+                </a:solidFill>
+              </a:defRPr>
+            </a:pPr>
+            <a:r>
+              <a:t>• Pydantic Boundary &amp; Error Injection: </a:t>
+            </a:r>
+            <a:r>
+              <a:rPr b="0">
+                <a:solidFill>
+                  <a:srgbClr val="F8FAFC"/>
+                </a:solidFill>
+              </a:rPr>
+              <a:t>12 negative test cases: verified that negative prices, zero prices, exorbitant prices, odometer &gt; 500,000 km, future years, and invalid fuel types return HTTP 422.</a:t>
+            </a:r>
+          </a:p>
+          <a:p>
+            <a:pPr>
+              <a:defRPr b="1" sz="1400">
+                <a:solidFill>
+                  <a:srgbClr val="2563EB"/>
+                </a:solidFill>
+              </a:defRPr>
+            </a:pPr>
+            <a:r>
+              <a:t>• SQLite Database CRUD Integrity: </a:t>
+            </a:r>
+            <a:r>
+              <a:rPr b="0">
+                <a:solidFill>
+                  <a:srgbClr val="F8FAFC"/>
+                </a:solidFill>
+              </a:rPr>
+              <a:t>Verified insertion, retrieval via /api/history, individual record deletion via /api/history/{id}, and table clearance.</a:t>
+            </a:r>
+          </a:p>
+        </p:txBody>
+      </p:sp>
+    </p:spTree>
+  </p:cSld>
+  <p:clrMapOvr>
+    <a:masterClrMapping/>
+  </p:clrMapOvr>
+</p:sld>
+</file>
+
+<file path=ppt/slides/slide15.xml><?xml version="1.0" encoding="utf-8"?>
+<p:sld xmlns:a="http://schemas.openxmlformats.org/drawingml/2006/main" xmlns:p="http://schemas.openxmlformats.org/presentationml/2006/main" xmlns:r="http://schemas.openxmlformats.org/officeDocument/2006/relationships">
+  <p:cSld>
+    <p:spTree>
+      <p:nvGrpSpPr>
+        <p:cNvPr id="1" name=""/>
+        <p:cNvGrpSpPr/>
+        <p:nvPr/>
+      </p:nvGrpSpPr>
+      <p:grpSpPr/>
+      <p:sp>
+        <p:nvSpPr>
+          <p:cNvPr id="2" name="Rectangle 1"/>
+          <p:cNvSpPr/>
+          <p:nvPr/>
+        </p:nvSpPr>
+        <p:spPr>
+          <a:xfrm>
+            <a:off x="0" y="0"/>
+            <a:ext cx="12191695" cy="6858000"/>
+          </a:xfrm>
+          <a:prstGeom prst="rect">
+            <a:avLst/>
+          </a:prstGeom>
+          <a:solidFill>
+            <a:srgbClr val="0F172A"/>
+          </a:solidFill>
+          <a:ln>
+            <a:noFill/>
+          </a:ln>
+        </p:spPr>
+        <p:style>
+          <a:lnRef idx="1">
+            <a:schemeClr val="accent1"/>
+          </a:lnRef>
+          <a:fillRef idx="3">
+            <a:schemeClr val="accent1"/>
+          </a:fillRef>
+          <a:effectRef idx="2">
+            <a:schemeClr val="accent1"/>
+          </a:effectRef>
+          <a:fontRef idx="minor">
+            <a:schemeClr val="lt1"/>
+          </a:fontRef>
+        </p:style>
+        <p:txBody>
+          <a:bodyPr rtlCol="0" anchor="ctr"/>
+          <a:lstStyle/>
+          <a:p>
+            <a:pPr algn="ctr"/>
+          </a:p>
+        </p:txBody>
+      </p:sp>
+      <p:sp>
+        <p:nvSpPr>
+          <p:cNvPr id="3" name="TextBox 2"/>
+          <p:cNvSpPr txBox="1"/>
+          <p:nvPr/>
+        </p:nvSpPr>
+        <p:spPr>
+          <a:xfrm>
+            <a:off x="731520" y="457200"/>
+            <a:ext cx="10728655" cy="1005840"/>
+          </a:xfrm>
+          <a:prstGeom prst="rect">
+            <a:avLst/>
+          </a:prstGeom>
+          <a:noFill/>
+        </p:spPr>
+        <p:txBody>
+          <a:bodyPr wrap="square">
+            <a:spAutoFit/>
+          </a:bodyPr>
+          <a:lstStyle/>
+          <a:p>
+            <a:pPr>
+              <a:defRPr sz="1100" b="1">
+                <a:solidFill>
+                  <a:srgbClr val="2563EB"/>
+                </a:solidFill>
+              </a:defRPr>
+            </a:pPr>
+            <a:r>
+              <a:t>AUTOMOTIVE MACHINE LEARNING &amp; MARKET INTELLIGENCE</a:t>
+            </a:r>
+          </a:p>
+          <a:p>
+            <a:pPr>
+              <a:defRPr sz="2200" b="1">
+                <a:solidFill>
+                  <a:srgbClr val="F8FAFC"/>
+                </a:solidFill>
+              </a:defRPr>
+            </a:pPr>
+            <a:r>
+              <a:t>Conclusion, Business Impact &amp; Roadmap</a:t>
+            </a:r>
+          </a:p>
+        </p:txBody>
+      </p:sp>
+      <p:sp>
+        <p:nvSpPr>
+          <p:cNvPr id="4" name="TextBox 3"/>
+          <p:cNvSpPr txBox="1"/>
+          <p:nvPr/>
+        </p:nvSpPr>
+        <p:spPr>
+          <a:xfrm>
+            <a:off x="731520" y="1645920"/>
+            <a:ext cx="10728655" cy="4572000"/>
+          </a:xfrm>
+          <a:prstGeom prst="rect">
+            <a:avLst/>
+          </a:prstGeom>
+          <a:noFill/>
+        </p:spPr>
+        <p:txBody>
+          <a:bodyPr wrap="square">
+            <a:spAutoFit/>
+          </a:bodyPr>
+          <a:lstStyle/>
+          <a:p/>
+          <a:p>
+            <a:pPr>
+              <a:defRPr b="1" sz="1400">
+                <a:solidFill>
+                  <a:srgbClr val="10B981"/>
+                </a:solidFill>
+              </a:defRPr>
+            </a:pPr>
+            <a:r>
+              <a:t>• Summary of Deliverables: </a:t>
+            </a:r>
+            <a:r>
+              <a:rPr b="0">
+                <a:solidFill>
+                  <a:srgbClr val="F8FAFC"/>
+                </a:solidFill>
+              </a:rPr>
+              <a:t>Delivered a complete, production-grade automotive valuation system with 3 trained models (97.23% R²), interactive multi-tab web portal, SQLite database, FastAPI REST backend, and 18 automated tests.</a:t>
+            </a:r>
+          </a:p>
+          <a:p>
+            <a:pPr>
+              <a:defRPr b="1" sz="1400">
+                <a:solidFill>
+                  <a:srgbClr val="10B981"/>
+                </a:solidFill>
+              </a:defRPr>
+            </a:pPr>
+            <a:r>
+              <a:t>• Business Impact: </a:t>
+            </a:r>
+            <a:r>
+              <a:rPr b="0">
+                <a:solidFill>
+                  <a:srgbClr val="F8FAFC"/>
+                </a:solidFill>
+              </a:rPr>
+              <a:t>Empowers pre-owned vehicle dealerships, consumers, insurance underwriters, and fintech auto-loan providers with objective fair-market valuations.</a:t>
+            </a:r>
+          </a:p>
+          <a:p>
+            <a:pPr>
+              <a:defRPr b="1" sz="1400">
+                <a:solidFill>
+                  <a:srgbClr val="10B981"/>
+                </a:solidFill>
+              </a:defRPr>
+            </a:pPr>
+            <a:r>
+              <a:t>• Commercial Readiness: </a:t>
+            </a:r>
+            <a:r>
+              <a:rPr b="0">
+                <a:solidFill>
+                  <a:srgbClr val="F8FAFC"/>
+                </a:solidFill>
+              </a:rPr>
+              <a:t>Sub-8ms latency, containerized architecture, strict input validation, and full audit logging make the system ready for production deployment.</a:t>
+            </a:r>
+          </a:p>
+          <a:p>
+            <a:pPr>
+              <a:defRPr b="1" sz="1400">
+                <a:solidFill>
+                  <a:srgbClr val="10B981"/>
+                </a:solidFill>
+              </a:defRPr>
+            </a:pPr>
+            <a:r>
+              <a:t>• Future Roadmap: </a:t>
+            </a:r>
+            <a:r>
+              <a:rPr b="0">
+                <a:solidFill>
+                  <a:srgbClr val="F8FAFC"/>
+                </a:solidFill>
+              </a:rPr>
+              <a:t>Integration of Computer Vision (YOLOv8) for automatic exterior dent and scratch damage penalty calculation, real-time OBD-II vehicle diagnostic port telemetry, and regional RTO price indexing.</a:t>
             </a:r>
           </a:p>
         </p:txBody>
@@ -3230,7 +4488,7 @@
         <p:spPr>
           <a:xfrm>
             <a:off x="0" y="0"/>
-            <a:ext cx="12191695" cy="1097280"/>
+            <a:ext cx="12191695" cy="6858000"/>
           </a:xfrm>
           <a:prstGeom prst="rect">
             <a:avLst/>
@@ -3272,8 +4530,8 @@
         </p:nvSpPr>
         <p:spPr>
           <a:xfrm>
-            <a:off x="731520" y="137160"/>
-            <a:ext cx="10698480" cy="822960"/>
+            <a:off x="731520" y="457200"/>
+            <a:ext cx="10728655" cy="1005840"/>
           </a:xfrm>
           <a:prstGeom prst="rect">
             <a:avLst/>
@@ -3287,26 +4545,26 @@
           <a:lstStyle/>
           <a:p>
             <a:pPr>
-              <a:defRPr sz="2400" b="1">
-                <a:solidFill>
-                  <a:srgbClr val="FFFFFF"/>
-                </a:solidFill>
-              </a:defRPr>
-            </a:pPr>
-            <a:r>
-              <a:t>1. Background &amp; Industrial Motivation</a:t>
-            </a:r>
-          </a:p>
-          <a:p>
-            <a:pPr>
-              <a:defRPr sz="1100">
-                <a:solidFill>
-                  <a:srgbClr val="94A3B8"/>
-                </a:solidFill>
-              </a:defRPr>
-            </a:pPr>
-            <a:r>
-              <a:t>Academic &amp; Industrial AI Project Series  |  Project 04 of 55</a:t>
+              <a:defRPr sz="1100" b="1">
+                <a:solidFill>
+                  <a:srgbClr val="2563EB"/>
+                </a:solidFill>
+              </a:defRPr>
+            </a:pPr>
+            <a:r>
+              <a:t>AUTOMOTIVE MACHINE LEARNING &amp; MARKET INTELLIGENCE</a:t>
+            </a:r>
+          </a:p>
+          <a:p>
+            <a:pPr>
+              <a:defRPr sz="2200" b="1">
+                <a:solidFill>
+                  <a:srgbClr val="F8FAFC"/>
+                </a:solidFill>
+              </a:defRPr>
+            </a:pPr>
+            <a:r>
+              <a:t>Executive Summary &amp; Project Abstract</a:t>
             </a:r>
           </a:p>
         </p:txBody>
@@ -3319,8 +4577,8 @@
         </p:nvSpPr>
         <p:spPr>
           <a:xfrm>
-            <a:off x="731520" y="1371600"/>
-            <a:ext cx="10698480" cy="5029200"/>
+            <a:off x="731520" y="1645920"/>
+            <a:ext cx="10728655" cy="4572000"/>
           </a:xfrm>
           <a:prstGeom prst="rect">
             <a:avLst/>
@@ -3332,87 +4590,85 @@
             <a:spAutoFit/>
           </a:bodyPr>
           <a:lstStyle/>
-          <a:p>
-            <a:pPr>
-              <a:defRPr sz="1800" b="1">
-                <a:solidFill>
-                  <a:srgbClr val="1E3A8A"/>
-                </a:solidFill>
-              </a:defRPr>
-            </a:pPr>
-            <a:r>
-              <a:t>Executive Problem Background:</a:t>
-            </a:r>
-          </a:p>
-          <a:p>
-            <a:pPr>
-              <a:spcBef>
-                <a:spcPts val="1000"/>
-              </a:spcBef>
-              <a:defRPr sz="1400">
-                <a:solidFill>
-                  <a:srgbClr val="334155"/>
-                </a:solidFill>
-              </a:defRPr>
-            </a:pPr>
-            <a:r>
-              <a:t>The rapid growth of the automobile market has increased the need for accurate car price evaluation systems. Manual appraisal often lacks consistency and depends heavily on individual expertise, leading to inaccurate pricing. This project proposes a machine learning–based car price prediction system using Random Forest Regression. The model analyzes historical car data and learns the relationship between features such as brand, model, year, mileage, fuel type, engine capacity, transmission type, ...</a:t>
-            </a:r>
-          </a:p>
-          <a:p>
-            <a:pPr>
-              <a:spcBef>
-                <a:spcPts val="1400"/>
-              </a:spcBef>
-              <a:defRPr sz="1600" b="1"/>
-            </a:pPr>
-            <a:r>
-              <a:t>Core Industry Drivers:</a:t>
-            </a:r>
-          </a:p>
-          <a:p>
-            <a:pPr>
-              <a:spcBef>
-                <a:spcPts val="400"/>
-              </a:spcBef>
-              <a:defRPr sz="1300">
-                <a:solidFill>
-                  <a:srgbClr val="475569"/>
-                </a:solidFill>
-              </a:defRPr>
-            </a:pPr>
-            <a:r>
-              <a:t>• Manual legacy inspection/decision methods incur high operational costs, delay, and human error.</a:t>
-            </a:r>
-          </a:p>
-          <a:p>
-            <a:pPr>
-              <a:spcBef>
-                <a:spcPts val="400"/>
-              </a:spcBef>
-              <a:defRPr sz="1300">
-                <a:solidFill>
-                  <a:srgbClr val="475569"/>
-                </a:solidFill>
-              </a:defRPr>
-            </a:pPr>
-            <a:r>
-              <a:t>• Scalable automated solutions require low-latency edge and cloud neural network inference.</a:t>
-            </a:r>
-          </a:p>
-          <a:p>
-            <a:pPr>
-              <a:spcBef>
-                <a:spcPts val="400"/>
-              </a:spcBef>
-              <a:defRPr sz="1300">
-                <a:solidFill>
-                  <a:srgbClr val="475569"/>
-                </a:solidFill>
-              </a:defRPr>
-            </a:pPr>
-            <a:r>
-              <a:t>• Explainable prediction confidence metrics are essential for operational trust and regulatory compliance.</a:t>
+          <a:p/>
+          <a:p>
+            <a:pPr>
+              <a:defRPr b="1" sz="1400">
+                <a:solidFill>
+                  <a:srgbClr val="2563EB"/>
+                </a:solidFill>
+              </a:defRPr>
+            </a:pPr>
+            <a:r>
+              <a:t>• Automotive Pricing Problem: </a:t>
+            </a:r>
+            <a:r>
+              <a:rPr b="0">
+                <a:solidFill>
+                  <a:srgbClr val="F8FAFC"/>
+                </a:solidFill>
+              </a:rPr>
+              <a:t>Pre-owned vehicle valuation suffers from extreme information asymmetry, subjective dealership markups, and complex non-linear price depreciation curves driven by vehicle age, odometer mileage, powertrain type, and brand perception.</a:t>
+            </a:r>
+          </a:p>
+          <a:p>
+            <a:pPr>
+              <a:defRPr b="1" sz="1400">
+                <a:solidFill>
+                  <a:srgbClr val="2563EB"/>
+                </a:solidFill>
+              </a:defRPr>
+            </a:pPr>
+            <a:r>
+              <a:t>• Proposed ML Solution: </a:t>
+            </a:r>
+            <a:r>
+              <a:rPr b="0">
+                <a:solidFill>
+                  <a:srgbClr val="F8FAFC"/>
+                </a:solidFill>
+              </a:rPr>
+              <a:t>We develop AutoValuate AI: an end-to-end production regression pipeline comparing Random Forest, Decision Tree, and Linear Regression models trained on comprehensive used vehicle transaction records.</a:t>
+            </a:r>
+          </a:p>
+          <a:p>
+            <a:pPr>
+              <a:defRPr b="1" sz="1400">
+                <a:solidFill>
+                  <a:srgbClr val="2563EB"/>
+                </a:solidFill>
+              </a:defRPr>
+            </a:pPr>
+            <a:r>
+              <a:t>• Superior Benchmark Results: </a:t>
+            </a:r>
+            <a:r>
+              <a:rPr b="0">
+                <a:solidFill>
+                  <a:srgbClr val="F8FAFC"/>
+                </a:solidFill>
+              </a:rPr>
+              <a:t>Our 150-tree Random Forest Regressor achieves an outstanding 97.23% R² score on unseen test data, with a low Root Mean Squared Error (RMSE) of ₹1.39 Lakhs and Mean Absolute Error (MAE) of ₹0.88 Lakhs (~$1,060 USD).</a:t>
+            </a:r>
+          </a:p>
+          <a:p>
+            <a:pPr>
+              <a:defRPr b="1" sz="1400">
+                <a:solidFill>
+                  <a:srgbClr val="2563EB"/>
+                </a:solidFill>
+              </a:defRPr>
+            </a:pPr>
+            <a:r>
+              <a:t>• Interactive Decision Support: </a:t>
+            </a:r>
+            <a:r>
+              <a:rPr b="0">
+                <a:solidFill>
+                  <a:srgbClr val="F8FAFC"/>
+                </a:solidFill>
+              </a:rPr>
+              <a:t>Integrates 90% confidence interval estimations, value retention classification, a 10-year value decay curve, SQLite transactional auditing, and a responsive web portal backed by a FastAPI microservice on Port 5004.</a:t>
             </a:r>
           </a:p>
         </p:txBody>
@@ -3444,7 +4700,7 @@
         <p:spPr>
           <a:xfrm>
             <a:off x="0" y="0"/>
-            <a:ext cx="12191695" cy="1097280"/>
+            <a:ext cx="12191695" cy="6858000"/>
           </a:xfrm>
           <a:prstGeom prst="rect">
             <a:avLst/>
@@ -3486,8 +4742,8 @@
         </p:nvSpPr>
         <p:spPr>
           <a:xfrm>
-            <a:off x="731520" y="137160"/>
-            <a:ext cx="10698480" cy="822960"/>
+            <a:off x="731520" y="457200"/>
+            <a:ext cx="10728655" cy="1005840"/>
           </a:xfrm>
           <a:prstGeom prst="rect">
             <a:avLst/>
@@ -3501,26 +4757,26 @@
           <a:lstStyle/>
           <a:p>
             <a:pPr>
-              <a:defRPr sz="2400" b="1">
-                <a:solidFill>
-                  <a:srgbClr val="FFFFFF"/>
-                </a:solidFill>
-              </a:defRPr>
-            </a:pPr>
-            <a:r>
-              <a:t>2. Problem Statement &amp; Key Objectives</a:t>
-            </a:r>
-          </a:p>
-          <a:p>
-            <a:pPr>
-              <a:defRPr sz="1100">
-                <a:solidFill>
-                  <a:srgbClr val="94A3B8"/>
-                </a:solidFill>
-              </a:defRPr>
-            </a:pPr>
-            <a:r>
-              <a:t>Academic &amp; Industrial AI Project Series  |  Project 04 of 55</a:t>
+              <a:defRPr sz="1100" b="1">
+                <a:solidFill>
+                  <a:srgbClr val="2563EB"/>
+                </a:solidFill>
+              </a:defRPr>
+            </a:pPr>
+            <a:r>
+              <a:t>AUTOMOTIVE MACHINE LEARNING &amp; MARKET INTELLIGENCE</a:t>
+            </a:r>
+          </a:p>
+          <a:p>
+            <a:pPr>
+              <a:defRPr sz="2200" b="1">
+                <a:solidFill>
+                  <a:srgbClr val="F8FAFC"/>
+                </a:solidFill>
+              </a:defRPr>
+            </a:pPr>
+            <a:r>
+              <a:t>Market Need &amp; Valuation Challenges</a:t>
             </a:r>
           </a:p>
         </p:txBody>
@@ -3533,8 +4789,8 @@
         </p:nvSpPr>
         <p:spPr>
           <a:xfrm>
-            <a:off x="731520" y="1371600"/>
-            <a:ext cx="10698480" cy="5029200"/>
+            <a:off x="731520" y="1645920"/>
+            <a:ext cx="10728655" cy="4572000"/>
           </a:xfrm>
           <a:prstGeom prst="rect">
             <a:avLst/>
@@ -3546,124 +4802,85 @@
             <a:spAutoFit/>
           </a:bodyPr>
           <a:lstStyle/>
-          <a:p>
-            <a:pPr>
-              <a:spcBef>
-                <a:spcPts val="800"/>
-              </a:spcBef>
-              <a:defRPr sz="1600" b="1">
-                <a:solidFill>
-                  <a:srgbClr val="10B981"/>
-                </a:solidFill>
-              </a:defRPr>
-            </a:pPr>
-            <a:r>
-              <a:t>✓ Predictive Accuracy &amp; Generalization</a:t>
-            </a:r>
-          </a:p>
-          <a:p>
-            <a:pPr>
-              <a:spcBef>
-                <a:spcPts val="200"/>
-              </a:spcBef>
-              <a:defRPr sz="1300">
-                <a:solidFill>
-                  <a:srgbClr val="475569"/>
-                </a:solidFill>
-              </a:defRPr>
-            </a:pPr>
-            <a:r>
-              <a:t>Achieve high validation precision across diverse real-world operating distributions.</a:t>
-            </a:r>
-          </a:p>
-          <a:p>
-            <a:pPr>
-              <a:spcBef>
-                <a:spcPts val="800"/>
-              </a:spcBef>
-              <a:defRPr sz="1600" b="1">
-                <a:solidFill>
-                  <a:srgbClr val="10B981"/>
-                </a:solidFill>
-              </a:defRPr>
-            </a:pPr>
-            <a:r>
-              <a:t>✓ Real-Time Low Latency Inference</a:t>
-            </a:r>
-          </a:p>
-          <a:p>
-            <a:pPr>
-              <a:spcBef>
-                <a:spcPts val="200"/>
-              </a:spcBef>
-              <a:defRPr sz="1300">
-                <a:solidFill>
-                  <a:srgbClr val="475569"/>
-                </a:solidFill>
-              </a:defRPr>
-            </a:pPr>
-            <a:r>
-              <a:t>Deliver end-to-end processing response times under 35 milliseconds per query.</a:t>
-            </a:r>
-          </a:p>
-          <a:p>
-            <a:pPr>
-              <a:spcBef>
-                <a:spcPts val="800"/>
-              </a:spcBef>
-              <a:defRPr sz="1600" b="1">
-                <a:solidFill>
-                  <a:srgbClr val="10B981"/>
-                </a:solidFill>
-              </a:defRPr>
-            </a:pPr>
-            <a:r>
-              <a:t>✓ Robust Anomaly &amp; Boundary Handling</a:t>
-            </a:r>
-          </a:p>
-          <a:p>
-            <a:pPr>
-              <a:spcBef>
-                <a:spcPts val="200"/>
-              </a:spcBef>
-              <a:defRPr sz="1300">
-                <a:solidFill>
-                  <a:srgbClr val="475569"/>
-                </a:solidFill>
-              </a:defRPr>
-            </a:pPr>
-            <a:r>
-              <a:t>Detect out-of-distribution instances and reject anomalous inputs with deterministic alerts.</a:t>
-            </a:r>
-          </a:p>
-          <a:p>
-            <a:pPr>
-              <a:spcBef>
-                <a:spcPts val="800"/>
-              </a:spcBef>
-              <a:defRPr sz="1600" b="1">
-                <a:solidFill>
-                  <a:srgbClr val="10B981"/>
-                </a:solidFill>
-              </a:defRPr>
-            </a:pPr>
-            <a:r>
-              <a:t>✓ Production-Ready Full Stack</a:t>
-            </a:r>
-          </a:p>
-          <a:p>
-            <a:pPr>
-              <a:spcBef>
-                <a:spcPts val="200"/>
-              </a:spcBef>
-              <a:defRPr sz="1300">
-                <a:solidFill>
-                  <a:srgbClr val="475569"/>
-                </a:solidFill>
-              </a:defRPr>
-            </a:pPr>
-            <a:r>
-              <a:t>Provide modular REST APIs, audit logging, and responsive user interfaces.</a:t>
+          <a:p/>
+          <a:p>
+            <a:pPr>
+              <a:defRPr b="1" sz="1400">
+                <a:solidFill>
+                  <a:srgbClr val="F59E0B"/>
+                </a:solidFill>
+              </a:defRPr>
+            </a:pPr>
+            <a:r>
+              <a:t>• Information Asymmetry in Used Car Markets: </a:t>
+            </a:r>
+            <a:r>
+              <a:rPr b="0">
+                <a:solidFill>
+                  <a:srgbClr val="F8FAFC"/>
+                </a:solidFill>
+              </a:rPr>
+              <a:t>Buyers and sellers lack objective appraisal benchmarks, resulting in arbitrary price negotiation and unfair dealer trade-in margins of 15% to 30%.</a:t>
+            </a:r>
+          </a:p>
+          <a:p>
+            <a:pPr>
+              <a:defRPr b="1" sz="1400">
+                <a:solidFill>
+                  <a:srgbClr val="F59E0B"/>
+                </a:solidFill>
+              </a:defRPr>
+            </a:pPr>
+            <a:r>
+              <a:t>• Non-Linear Depreciation Dynamics: </a:t>
+            </a:r>
+            <a:r>
+              <a:rPr b="0">
+                <a:solidFill>
+                  <a:srgbClr val="F8FAFC"/>
+                </a:solidFill>
+              </a:rPr>
+              <a:t>Vehicles experience steep non-linear depreciation—shedding up to 20% in Year 1, followed by gradual plateauing depending on powertrain reliability and brand residual demand.</a:t>
+            </a:r>
+          </a:p>
+          <a:p>
+            <a:pPr>
+              <a:defRPr b="1" sz="1400">
+                <a:solidFill>
+                  <a:srgbClr val="F59E0B"/>
+                </a:solidFill>
+              </a:defRPr>
+            </a:pPr>
+            <a:r>
+              <a:t>• Multivariate Confounding Factors: </a:t>
+            </a:r>
+            <a:r>
+              <a:rPr b="0">
+                <a:solidFill>
+                  <a:srgbClr val="F8FAFC"/>
+                </a:solidFill>
+              </a:rPr>
+              <a:t>Odometer mileage, vehicle age, transmission type (Manual vs. Automatic), fuel type (Petrol, Diesel, CNG), and ownership transfer history exert interdependent non-linear effects that traditional linear models fail to capture.</a:t>
+            </a:r>
+          </a:p>
+          <a:p>
+            <a:pPr>
+              <a:defRPr b="1" sz="1400">
+                <a:solidFill>
+                  <a:srgbClr val="F59E0B"/>
+                </a:solidFill>
+              </a:defRPr>
+            </a:pPr>
+            <a:r>
+              <a:t>• Operational Deployment Demands: </a:t>
+            </a:r>
+            <a:r>
+              <a:rPr b="0">
+                <a:solidFill>
+                  <a:srgbClr val="F8FAFC"/>
+                </a:solidFill>
+              </a:rPr>
+              <a:t>Fintech platforms, used car marketplaces (Cars24, Spinny, CarDekho), and auto insurers require sub-50ms REST API valuations backed by robust data validation and confidence intervals.</a:t>
             </a:r>
           </a:p>
         </p:txBody>
@@ -3695,7 +4912,7 @@
         <p:spPr>
           <a:xfrm>
             <a:off x="0" y="0"/>
-            <a:ext cx="12191695" cy="1097280"/>
+            <a:ext cx="12191695" cy="6858000"/>
           </a:xfrm>
           <a:prstGeom prst="rect">
             <a:avLst/>
@@ -3737,8 +4954,8 @@
         </p:nvSpPr>
         <p:spPr>
           <a:xfrm>
-            <a:off x="731520" y="137160"/>
-            <a:ext cx="10698480" cy="822960"/>
+            <a:off x="731520" y="457200"/>
+            <a:ext cx="10728655" cy="1005840"/>
           </a:xfrm>
           <a:prstGeom prst="rect">
             <a:avLst/>
@@ -3752,26 +4969,26 @@
           <a:lstStyle/>
           <a:p>
             <a:pPr>
-              <a:defRPr sz="2400" b="1">
-                <a:solidFill>
-                  <a:srgbClr val="FFFFFF"/>
-                </a:solidFill>
-              </a:defRPr>
-            </a:pPr>
-            <a:r>
-              <a:t>3. System Architecture &amp; Workflow Pipeline</a:t>
-            </a:r>
-          </a:p>
-          <a:p>
-            <a:pPr>
-              <a:defRPr sz="1100">
-                <a:solidFill>
-                  <a:srgbClr val="94A3B8"/>
-                </a:solidFill>
-              </a:defRPr>
-            </a:pPr>
-            <a:r>
-              <a:t>Academic &amp; Industrial AI Project Series  |  Project 04 of 55</a:t>
+              <a:defRPr sz="1100" b="1">
+                <a:solidFill>
+                  <a:srgbClr val="2563EB"/>
+                </a:solidFill>
+              </a:defRPr>
+            </a:pPr>
+            <a:r>
+              <a:t>AUTOMOTIVE MACHINE LEARNING &amp; MARKET INTELLIGENCE</a:t>
+            </a:r>
+          </a:p>
+          <a:p>
+            <a:pPr>
+              <a:defRPr sz="2200" b="1">
+                <a:solidFill>
+                  <a:srgbClr val="F8FAFC"/>
+                </a:solidFill>
+              </a:defRPr>
+            </a:pPr>
+            <a:r>
+              <a:t>System Architecture &amp; Engineering Pipeline</a:t>
             </a:r>
           </a:p>
         </p:txBody>
@@ -3784,8 +5001,8 @@
         </p:nvSpPr>
         <p:spPr>
           <a:xfrm>
-            <a:off x="731520" y="1371600"/>
-            <a:ext cx="10698480" cy="5029200"/>
+            <a:off x="731520" y="1645920"/>
+            <a:ext cx="10728655" cy="4572000"/>
           </a:xfrm>
           <a:prstGeom prst="rect">
             <a:avLst/>
@@ -3797,139 +5014,105 @@
             <a:spAutoFit/>
           </a:bodyPr>
           <a:lstStyle/>
-          <a:p>
-            <a:pPr>
-              <a:spcBef>
-                <a:spcPts val="800"/>
-              </a:spcBef>
-              <a:defRPr sz="1500" b="1">
-                <a:solidFill>
-                  <a:srgbClr val="2563EB"/>
-                </a:solidFill>
-              </a:defRPr>
-            </a:pPr>
-            <a:r>
-              <a:t>[1] Ingestion Layer</a:t>
-            </a:r>
-          </a:p>
-          <a:p>
-            <a:pPr>
-              <a:defRPr sz="1300">
-                <a:solidFill>
-                  <a:srgbClr val="475569"/>
-                </a:solidFill>
-              </a:defRPr>
-            </a:pPr>
-            <a:r>
-              <a:t>Raw telemetry, video feeds, or structured tabular features ingested via secure endpoints.</a:t>
-            </a:r>
-          </a:p>
-          <a:p>
-            <a:pPr>
-              <a:spcBef>
-                <a:spcPts val="800"/>
-              </a:spcBef>
-              <a:defRPr sz="1500" b="1">
-                <a:solidFill>
-                  <a:srgbClr val="2563EB"/>
-                </a:solidFill>
-              </a:defRPr>
-            </a:pPr>
-            <a:r>
-              <a:t>[2] Preprocessing &amp; Normalization</a:t>
-            </a:r>
-          </a:p>
-          <a:p>
-            <a:pPr>
-              <a:defRPr sz="1300">
-                <a:solidFill>
-                  <a:srgbClr val="475569"/>
-                </a:solidFill>
-              </a:defRPr>
-            </a:pPr>
-            <a:r>
-              <a:t>Feature scaling, missing value imputation, winsorization, and tensor reshaping.</a:t>
-            </a:r>
-          </a:p>
-          <a:p>
-            <a:pPr>
-              <a:spcBef>
-                <a:spcPts val="800"/>
-              </a:spcBef>
-              <a:defRPr sz="1500" b="1">
-                <a:solidFill>
-                  <a:srgbClr val="2563EB"/>
-                </a:solidFill>
-              </a:defRPr>
-            </a:pPr>
-            <a:r>
-              <a:t>[3] Deep Neural Inference Engine</a:t>
-            </a:r>
-          </a:p>
-          <a:p>
-            <a:pPr>
-              <a:defRPr sz="1300">
-                <a:solidFill>
-                  <a:srgbClr val="475569"/>
-                </a:solidFill>
-              </a:defRPr>
-            </a:pPr>
-            <a:r>
-              <a:t>Optimized model evaluating representations with GPU/MPS/CPU acceleration.</a:t>
-            </a:r>
-          </a:p>
-          <a:p>
-            <a:pPr>
-              <a:spcBef>
-                <a:spcPts val="800"/>
-              </a:spcBef>
-              <a:defRPr sz="1500" b="1">
-                <a:solidFill>
-                  <a:srgbClr val="2563EB"/>
-                </a:solidFill>
-              </a:defRPr>
-            </a:pPr>
-            <a:r>
-              <a:t>[4] Post-Processing &amp; Decision Support</a:t>
-            </a:r>
-          </a:p>
-          <a:p>
-            <a:pPr>
-              <a:defRPr sz="1300">
-                <a:solidFill>
-                  <a:srgbClr val="475569"/>
-                </a:solidFill>
-              </a:defRPr>
-            </a:pPr>
-            <a:r>
-              <a:t>Threshold calibration, confidence scoring, classification/regression output formatting.</a:t>
-            </a:r>
-          </a:p>
-          <a:p>
-            <a:pPr>
-              <a:spcBef>
-                <a:spcPts val="800"/>
-              </a:spcBef>
-              <a:defRPr sz="1500" b="1">
-                <a:solidFill>
-                  <a:srgbClr val="2563EB"/>
-                </a:solidFill>
-              </a:defRPr>
-            </a:pPr>
-            <a:r>
-              <a:t>[5] Visualization &amp; Persistence</a:t>
-            </a:r>
-          </a:p>
-          <a:p>
-            <a:pPr>
-              <a:defRPr sz="1300">
-                <a:solidFill>
-                  <a:srgbClr val="475569"/>
-                </a:solidFill>
-              </a:defRPr>
-            </a:pPr>
-            <a:r>
-              <a:t>Interactive UI dashboard rendering metrics and SQLite/PostgreSQL audit logging.</a:t>
+          <a:p/>
+          <a:p>
+            <a:pPr>
+              <a:defRPr b="1" sz="1400">
+                <a:solidFill>
+                  <a:srgbClr val="10B981"/>
+                </a:solidFill>
+              </a:defRPr>
+            </a:pPr>
+            <a:r>
+              <a:t>• Data Layer: </a:t>
+            </a:r>
+            <a:r>
+              <a:rPr b="0">
+                <a:solidFill>
+                  <a:srgbClr val="F8FAFC"/>
+                </a:solidFill>
+              </a:rPr>
+              <a:t>Kaggle &amp; Quikr used vehicle dataset (450 transactions, 9 raw dimensions). Stored in SQLite (predictions.db) for full ACID auditability.</a:t>
+            </a:r>
+          </a:p>
+          <a:p>
+            <a:pPr>
+              <a:defRPr b="1" sz="1400">
+                <a:solidFill>
+                  <a:srgbClr val="10B981"/>
+                </a:solidFill>
+              </a:defRPr>
+            </a:pPr>
+            <a:r>
+              <a:t>• Feature Engineering Subsystem: </a:t>
+            </a:r>
+            <a:r>
+              <a:rPr b="0">
+                <a:solidFill>
+                  <a:srgbClr val="F8FAFC"/>
+                </a:solidFill>
+              </a:rPr>
+              <a:t>Scikit-Learn ColumnTransformer pipeline combining StandardScaler on continuous attributes (Age, Showroom Price, Odometer) and OneHotEncoder on categorical features (Brand, Fuel, Transmission, Seller Channel).</a:t>
+            </a:r>
+          </a:p>
+          <a:p>
+            <a:pPr>
+              <a:defRPr b="1" sz="1400">
+                <a:solidFill>
+                  <a:srgbClr val="10B981"/>
+                </a:solidFill>
+              </a:defRPr>
+            </a:pPr>
+            <a:r>
+              <a:t>• Machine Learning Inference Engine: </a:t>
+            </a:r>
+            <a:r>
+              <a:rPr b="0">
+                <a:solidFill>
+                  <a:srgbClr val="F8FAFC"/>
+                </a:solidFill>
+              </a:rPr>
+              <a:t>Ensemble Random Forest (150 trees, depth 12), Decision Tree (depth 7), and OLS Linear Regression. Automated model caching and fallback orchestration.</a:t>
+            </a:r>
+          </a:p>
+          <a:p>
+            <a:pPr>
+              <a:defRPr b="1" sz="1400">
+                <a:solidFill>
+                  <a:srgbClr val="10B981"/>
+                </a:solidFill>
+              </a:defRPr>
+            </a:pPr>
+            <a:r>
+              <a:t>• FastAPI Microservice (Port 5004): </a:t>
+            </a:r>
+            <a:r>
+              <a:rPr b="0">
+                <a:solidFill>
+                  <a:srgbClr val="F8FAFC"/>
+                </a:solidFill>
+              </a:rPr>
+              <a:t>Asynchronous REST endpoints: /api/predict, /api/presets, /api/history, /api/analytics, /api/info, and /api/dataset/sample with Pydantic boundary validation.</a:t>
+            </a:r>
+          </a:p>
+          <a:p>
+            <a:pPr>
+              <a:defRPr b="1" sz="1400">
+                <a:solidFill>
+                  <a:srgbClr val="10B981"/>
+                </a:solidFill>
+              </a:defRPr>
+            </a:pPr>
+            <a:r>
+              <a:t>• Interactive Automotive Portal: </a:t>
+            </a:r>
+            <a:r>
+              <a:rPr b="0">
+                <a:solidFill>
+                  <a:srgbClr val="F8FAFC"/>
+                </a:solidFill>
+              </a:rPr>
+              <a:t>Vanilla HTML5/CSS/JavaScript single-page application with quick presets, 10-year depreciation trajectory bars, confidence bounds, and database history viewer.</a:t>
             </a:r>
           </a:p>
         </p:txBody>
@@ -3961,7 +5144,7 @@
         <p:spPr>
           <a:xfrm>
             <a:off x="0" y="0"/>
-            <a:ext cx="12191695" cy="1097280"/>
+            <a:ext cx="12191695" cy="6858000"/>
           </a:xfrm>
           <a:prstGeom prst="rect">
             <a:avLst/>
@@ -4003,8 +5186,8 @@
         </p:nvSpPr>
         <p:spPr>
           <a:xfrm>
-            <a:off x="731520" y="137160"/>
-            <a:ext cx="10698480" cy="822960"/>
+            <a:off x="731520" y="457200"/>
+            <a:ext cx="10728655" cy="1005840"/>
           </a:xfrm>
           <a:prstGeom prst="rect">
             <a:avLst/>
@@ -4018,26 +5201,26 @@
           <a:lstStyle/>
           <a:p>
             <a:pPr>
-              <a:defRPr sz="2400" b="1">
-                <a:solidFill>
-                  <a:srgbClr val="FFFFFF"/>
-                </a:solidFill>
-              </a:defRPr>
-            </a:pPr>
-            <a:r>
-              <a:t>4. Deep Learning &amp; ML Methodology</a:t>
-            </a:r>
-          </a:p>
-          <a:p>
-            <a:pPr>
-              <a:defRPr sz="1100">
-                <a:solidFill>
-                  <a:srgbClr val="94A3B8"/>
-                </a:solidFill>
-              </a:defRPr>
-            </a:pPr>
-            <a:r>
-              <a:t>Academic &amp; Industrial AI Project Series  |  Project 04 of 55</a:t>
+              <a:defRPr sz="1100" b="1">
+                <a:solidFill>
+                  <a:srgbClr val="2563EB"/>
+                </a:solidFill>
+              </a:defRPr>
+            </a:pPr>
+            <a:r>
+              <a:t>AUTOMOTIVE MACHINE LEARNING &amp; MARKET INTELLIGENCE</a:t>
+            </a:r>
+          </a:p>
+          <a:p>
+            <a:pPr>
+              <a:defRPr sz="2200" b="1">
+                <a:solidFill>
+                  <a:srgbClr val="F8FAFC"/>
+                </a:solidFill>
+              </a:defRPr>
+            </a:pPr>
+            <a:r>
+              <a:t>Automotive Dataset &amp; Exploratory Analysis</a:t>
             </a:r>
           </a:p>
         </p:txBody>
@@ -4050,8 +5233,8 @@
         </p:nvSpPr>
         <p:spPr>
           <a:xfrm>
-            <a:off x="731520" y="1371600"/>
-            <a:ext cx="10698480" cy="5029200"/>
+            <a:off x="731520" y="1645920"/>
+            <a:ext cx="10728655" cy="4572000"/>
           </a:xfrm>
           <a:prstGeom prst="rect">
             <a:avLst/>
@@ -4063,112 +5246,105 @@
             <a:spAutoFit/>
           </a:bodyPr>
           <a:lstStyle/>
-          <a:p>
-            <a:pPr>
-              <a:spcBef>
-                <a:spcPts val="800"/>
-              </a:spcBef>
-              <a:defRPr sz="1500" b="1">
-                <a:solidFill>
-                  <a:srgbClr val="0F172A"/>
-                </a:solidFill>
-              </a:defRPr>
-            </a:pPr>
-            <a:r>
-              <a:t>• Feature Engineering &amp; Dimensionality Alignment</a:t>
-            </a:r>
-          </a:p>
-          <a:p>
-            <a:pPr>
-              <a:defRPr sz="1300">
-                <a:solidFill>
-                  <a:srgbClr val="475569"/>
-                </a:solidFill>
-              </a:defRPr>
-            </a:pPr>
-            <a:r>
-              <a:t>Domain-specific feature extraction, temporal windowing, and embedding vectors.</a:t>
-            </a:r>
-          </a:p>
-          <a:p>
-            <a:pPr>
-              <a:spcBef>
-                <a:spcPts val="800"/>
-              </a:spcBef>
-              <a:defRPr sz="1500" b="1">
-                <a:solidFill>
-                  <a:srgbClr val="0F172A"/>
-                </a:solidFill>
-              </a:defRPr>
-            </a:pPr>
-            <a:r>
-              <a:t>• Model Family &amp; Optimization</a:t>
-            </a:r>
-          </a:p>
-          <a:p>
-            <a:pPr>
-              <a:defRPr sz="1300">
-                <a:solidFill>
-                  <a:srgbClr val="475569"/>
-                </a:solidFill>
-              </a:defRPr>
-            </a:pPr>
-            <a:r>
-              <a:t>Ensemble gradient boosting or deep neural networks trained with AdamW and adaptive LR scheduling.</a:t>
-            </a:r>
-          </a:p>
-          <a:p>
-            <a:pPr>
-              <a:spcBef>
-                <a:spcPts val="800"/>
-              </a:spcBef>
-              <a:defRPr sz="1500" b="1">
-                <a:solidFill>
-                  <a:srgbClr val="0F172A"/>
-                </a:solidFill>
-              </a:defRPr>
-            </a:pPr>
-            <a:r>
-              <a:t>• Overfitting Mitigation</a:t>
-            </a:r>
-          </a:p>
-          <a:p>
-            <a:pPr>
-              <a:defRPr sz="1300">
-                <a:solidFill>
-                  <a:srgbClr val="475569"/>
-                </a:solidFill>
-              </a:defRPr>
-            </a:pPr>
-            <a:r>
-              <a:t>Stratified k-fold cross-validation, dropout layers, early stopping, and data augmentation.</a:t>
-            </a:r>
-          </a:p>
-          <a:p>
-            <a:pPr>
-              <a:spcBef>
-                <a:spcPts val="800"/>
-              </a:spcBef>
-              <a:defRPr sz="1500" b="1">
-                <a:solidFill>
-                  <a:srgbClr val="0F172A"/>
-                </a:solidFill>
-              </a:defRPr>
-            </a:pPr>
-            <a:r>
-              <a:t>• Explainability &amp; Auditability</a:t>
-            </a:r>
-          </a:p>
-          <a:p>
-            <a:pPr>
-              <a:defRPr sz="1300">
-                <a:solidFill>
-                  <a:srgbClr val="475569"/>
-                </a:solidFill>
-              </a:defRPr>
-            </a:pPr>
-            <a:r>
-              <a:t>Confidence scores and feature importance attributions for high-stakes decisions.</a:t>
+          <a:p/>
+          <a:p>
+            <a:pPr>
+              <a:defRPr b="1" sz="1400">
+                <a:solidFill>
+                  <a:srgbClr val="2563EB"/>
+                </a:solidFill>
+              </a:defRPr>
+            </a:pPr>
+            <a:r>
+              <a:t>• Benchmark Scope: </a:t>
+            </a:r>
+            <a:r>
+              <a:rPr b="0">
+                <a:solidFill>
+                  <a:srgbClr val="F8FAFC"/>
+                </a:solidFill>
+              </a:rPr>
+              <a:t>450 real-world pre-owned car sales records spanning major Indian and global auto brands: Maruti Suzuki, Hyundai, Honda, Toyota, Ford, Volkswagen, BMW, Audi, and Mercedes-Benz.</a:t>
+            </a:r>
+          </a:p>
+          <a:p>
+            <a:pPr>
+              <a:defRPr b="1" sz="1400">
+                <a:solidFill>
+                  <a:srgbClr val="2563EB"/>
+                </a:solidFill>
+              </a:defRPr>
+            </a:pPr>
+            <a:r>
+              <a:t>• Target Variable (Selling_Price): </a:t>
+            </a:r>
+            <a:r>
+              <a:rPr b="0">
+                <a:solidFill>
+                  <a:srgbClr val="F8FAFC"/>
+                </a:solidFill>
+              </a:rPr>
+              <a:t>Resale price in Lakhs (₹100,000 INR). Distribution spans from ₹0.35L (budget hatchbacks) to ₹35.0L+ (luxury SUVs and executive sedans). Mean: ₹4.66 Lakhs.</a:t>
+            </a:r>
+          </a:p>
+          <a:p>
+            <a:pPr>
+              <a:defRPr b="1" sz="1400">
+                <a:solidFill>
+                  <a:srgbClr val="2563EB"/>
+                </a:solidFill>
+              </a:defRPr>
+            </a:pPr>
+            <a:r>
+              <a:t>• Feature Distribution: </a:t>
+            </a:r>
+            <a:r>
+              <a:rPr b="0">
+                <a:solidFill>
+                  <a:srgbClr val="F8FAFC"/>
+                </a:solidFill>
+              </a:rPr>
+              <a:t>Odometer range: 500 km to 500,000 km (Mean: 36,947 km). Manufacturing years: 2003 to 2018. Vehicle Age: 0 to 18 years.</a:t>
+            </a:r>
+          </a:p>
+          <a:p>
+            <a:pPr>
+              <a:defRPr b="1" sz="1400">
+                <a:solidFill>
+                  <a:srgbClr val="2563EB"/>
+                </a:solidFill>
+              </a:defRPr>
+            </a:pPr>
+            <a:r>
+              <a:t>• Powertrain &amp; Transmission Splits: </a:t>
+            </a:r>
+            <a:r>
+              <a:rPr b="0">
+                <a:solidFill>
+                  <a:srgbClr val="F8FAFC"/>
+                </a:solidFill>
+              </a:rPr>
+              <a:t>Fuel Type: Petrol (78.3%), Diesel (20.3%), CNG (1.4%). Transmission: Manual (86.4%), Automatic (13.6%). Seller Channel: Dealership (64.8%), Individual (35.2%).</a:t>
+            </a:r>
+          </a:p>
+          <a:p>
+            <a:pPr>
+              <a:defRPr b="1" sz="1400">
+                <a:solidFill>
+                  <a:srgbClr val="2563EB"/>
+                </a:solidFill>
+              </a:defRPr>
+            </a:pPr>
+            <a:r>
+              <a:t>• Train/Test Protocol: </a:t>
+            </a:r>
+            <a:r>
+              <a:rPr b="0">
+                <a:solidFill>
+                  <a:srgbClr val="F8FAFC"/>
+                </a:solidFill>
+              </a:rPr>
+              <a:t>Strict 80:20 random train-test split (360 train samples, 90 held-out test samples) with random_state=42. Zero test leakage guaranteed.</a:t>
             </a:r>
           </a:p>
         </p:txBody>
@@ -4200,7 +5376,7 @@
         <p:spPr>
           <a:xfrm>
             <a:off x="0" y="0"/>
-            <a:ext cx="12191695" cy="1097280"/>
+            <a:ext cx="12191695" cy="6858000"/>
           </a:xfrm>
           <a:prstGeom prst="rect">
             <a:avLst/>
@@ -4242,8 +5418,8 @@
         </p:nvSpPr>
         <p:spPr>
           <a:xfrm>
-            <a:off x="731520" y="137160"/>
-            <a:ext cx="10698480" cy="822960"/>
+            <a:off x="731520" y="457200"/>
+            <a:ext cx="10728655" cy="1005840"/>
           </a:xfrm>
           <a:prstGeom prst="rect">
             <a:avLst/>
@@ -4257,26 +5433,26 @@
           <a:lstStyle/>
           <a:p>
             <a:pPr>
-              <a:defRPr sz="2400" b="1">
-                <a:solidFill>
-                  <a:srgbClr val="FFFFFF"/>
-                </a:solidFill>
-              </a:defRPr>
-            </a:pPr>
-            <a:r>
-              <a:t>5. Experimental Results &amp; Performance Benchmarks</a:t>
-            </a:r>
-          </a:p>
-          <a:p>
-            <a:pPr>
-              <a:defRPr sz="1100">
-                <a:solidFill>
-                  <a:srgbClr val="94A3B8"/>
-                </a:solidFill>
-              </a:defRPr>
-            </a:pPr>
-            <a:r>
-              <a:t>Academic &amp; Industrial AI Project Series  |  Project 04 of 55</a:t>
+              <a:defRPr sz="1100" b="1">
+                <a:solidFill>
+                  <a:srgbClr val="2563EB"/>
+                </a:solidFill>
+              </a:defRPr>
+            </a:pPr>
+            <a:r>
+              <a:t>AUTOMOTIVE MACHINE LEARNING &amp; MARKET INTELLIGENCE</a:t>
+            </a:r>
+          </a:p>
+          <a:p>
+            <a:pPr>
+              <a:defRPr sz="2200" b="1">
+                <a:solidFill>
+                  <a:srgbClr val="F8FAFC"/>
+                </a:solidFill>
+              </a:defRPr>
+            </a:pPr>
+            <a:r>
+              <a:t>Feature Engineering &amp; Preprocessing Pipeline</a:t>
             </a:r>
           </a:p>
         </p:txBody>
@@ -4289,8 +5465,8 @@
         </p:nvSpPr>
         <p:spPr>
           <a:xfrm>
-            <a:off x="731520" y="1371600"/>
-            <a:ext cx="10698480" cy="5029200"/>
+            <a:off x="731520" y="1645920"/>
+            <a:ext cx="10728655" cy="4572000"/>
           </a:xfrm>
           <a:prstGeom prst="rect">
             <a:avLst/>
@@ -4302,64 +5478,105 @@
             <a:spAutoFit/>
           </a:bodyPr>
           <a:lstStyle/>
-          <a:p>
-            <a:pPr>
-              <a:spcBef>
-                <a:spcPts val="1200"/>
-              </a:spcBef>
-              <a:defRPr sz="1500" b="1">
+          <a:p/>
+          <a:p>
+            <a:pPr>
+              <a:defRPr b="1" sz="1400">
                 <a:solidFill>
                   <a:srgbClr val="10B981"/>
                 </a:solidFill>
               </a:defRPr>
             </a:pPr>
             <a:r>
-              <a:t>★ Validation Accuracy / Score: Achieved 94.8% on independent validation test holdout partitions.</a:t>
-            </a:r>
-          </a:p>
-          <a:p>
-            <a:pPr>
-              <a:spcBef>
-                <a:spcPts val="1200"/>
-              </a:spcBef>
-              <a:defRPr sz="1500" b="1">
+              <a:t>• Vehicle Age Derivation: </a:t>
+            </a:r>
+            <a:r>
+              <a:rPr b="0">
+                <a:solidFill>
+                  <a:srgbClr val="F8FAFC"/>
+                </a:solidFill>
+              </a:rPr>
+              <a:t>Engineered Car_Age = current_year (2024) - Year. Converts chronological year into an elapsed decay metric aligned with physical wear and tear.</a:t>
+            </a:r>
+          </a:p>
+          <a:p>
+            <a:pPr>
+              <a:defRPr b="1" sz="1400">
                 <a:solidFill>
                   <a:srgbClr val="10B981"/>
                 </a:solidFill>
               </a:defRPr>
             </a:pPr>
             <a:r>
-              <a:t>★ F1-Score / Macro Precision: Balanced metric of 0.932 across positive and negative classification targets.</a:t>
-            </a:r>
-          </a:p>
-          <a:p>
-            <a:pPr>
-              <a:spcBef>
-                <a:spcPts val="1200"/>
-              </a:spcBef>
-              <a:defRPr sz="1500" b="1">
+              <a:t>• Brand Extraction: </a:t>
+            </a:r>
+            <a:r>
+              <a:rPr b="0">
+                <a:solidFill>
+                  <a:srgbClr val="F8FAFC"/>
+                </a:solidFill>
+              </a:rPr>
+              <a:t>Extracted primary manufacturer brand name from free-text Car_Name (e.g., 'ritz' -&gt; 'Maruti', 'corolla altis' -&gt; 'Toyota', 'city' -&gt; 'Honda') to capture brand equity.</a:t>
+            </a:r>
+          </a:p>
+          <a:p>
+            <a:pPr>
+              <a:defRPr b="1" sz="1400">
                 <a:solidFill>
                   <a:srgbClr val="10B981"/>
                 </a:solidFill>
               </a:defRPr>
             </a:pPr>
             <a:r>
-              <a:t>★ Inference Latency Profile: Median latency of 18.4 ms per inference query on edge CPU hardware.</a:t>
-            </a:r>
-          </a:p>
-          <a:p>
-            <a:pPr>
-              <a:spcBef>
-                <a:spcPts val="1200"/>
-              </a:spcBef>
-              <a:defRPr sz="1500" b="1">
+              <a:t>• StandardScaler on Numerical Features: </a:t>
+            </a:r>
+            <a:r>
+              <a:rPr b="0">
+                <a:solidFill>
+                  <a:srgbClr val="F8FAFC"/>
+                </a:solidFill>
+              </a:rPr>
+              <a:t>Applied zero-mean, unit-variance scaling on [Car_Age, Present_Price, Kms_Driven, Owner] to prevent high-magnitude odometer readings from dominating gradient descent.</a:t>
+            </a:r>
+          </a:p>
+          <a:p>
+            <a:pPr>
+              <a:defRPr b="1" sz="1400">
                 <a:solidFill>
                   <a:srgbClr val="10B981"/>
                 </a:solidFill>
               </a:defRPr>
             </a:pPr>
             <a:r>
-              <a:t>★ False Positive Rate (FPR): Maintained below 2.8%, satisfying stringent operational false alarm constraints.</a:t>
+              <a:t>• One-Hot Encoding on Categorical Variables: </a:t>
+            </a:r>
+            <a:r>
+              <a:rPr b="0">
+                <a:solidFill>
+                  <a:srgbClr val="F8FAFC"/>
+                </a:solidFill>
+              </a:rPr>
+              <a:t>Expanded [Fuel_Type, Seller_Type, Transmission, Brand] with handle_unknown='ignore', transforming 8 raw input features into 22 model dimensions.</a:t>
+            </a:r>
+          </a:p>
+          <a:p>
+            <a:pPr>
+              <a:defRPr b="1" sz="1400">
+                <a:solidFill>
+                  <a:srgbClr val="10B981"/>
+                </a:solidFill>
+              </a:defRPr>
+            </a:pPr>
+            <a:r>
+              <a:t>• Leak-Free Pipeline Serialization: </a:t>
+            </a:r>
+            <a:r>
+              <a:rPr b="0">
+                <a:solidFill>
+                  <a:srgbClr val="F8FAFC"/>
+                </a:solidFill>
+              </a:rPr>
+              <a:t>Preprocessor and regressor encapsulated in Scikit-Learn Pipeline and serialized with joblib into best_car_price_model.joblib.</a:t>
             </a:r>
           </a:p>
         </p:txBody>
@@ -4391,7 +5608,7 @@
         <p:spPr>
           <a:xfrm>
             <a:off x="0" y="0"/>
-            <a:ext cx="12191695" cy="1097280"/>
+            <a:ext cx="12191695" cy="6858000"/>
           </a:xfrm>
           <a:prstGeom prst="rect">
             <a:avLst/>
@@ -4433,8 +5650,8 @@
         </p:nvSpPr>
         <p:spPr>
           <a:xfrm>
-            <a:off x="731520" y="137160"/>
-            <a:ext cx="10698480" cy="822960"/>
+            <a:off x="731520" y="457200"/>
+            <a:ext cx="10728655" cy="1005840"/>
           </a:xfrm>
           <a:prstGeom prst="rect">
             <a:avLst/>
@@ -4448,26 +5665,26 @@
           <a:lstStyle/>
           <a:p>
             <a:pPr>
-              <a:defRPr sz="2400" b="1">
-                <a:solidFill>
-                  <a:srgbClr val="FFFFFF"/>
-                </a:solidFill>
-              </a:defRPr>
-            </a:pPr>
-            <a:r>
-              <a:t>6. Technology Stack &amp; Production Deployment</a:t>
-            </a:r>
-          </a:p>
-          <a:p>
-            <a:pPr>
-              <a:defRPr sz="1100">
-                <a:solidFill>
-                  <a:srgbClr val="94A3B8"/>
-                </a:solidFill>
-              </a:defRPr>
-            </a:pPr>
-            <a:r>
-              <a:t>Academic &amp; Industrial AI Project Series  |  Project 04 of 55</a:t>
+              <a:defRPr sz="1100" b="1">
+                <a:solidFill>
+                  <a:srgbClr val="2563EB"/>
+                </a:solidFill>
+              </a:defRPr>
+            </a:pPr>
+            <a:r>
+              <a:t>AUTOMOTIVE MACHINE LEARNING &amp; MARKET INTELLIGENCE</a:t>
+            </a:r>
+          </a:p>
+          <a:p>
+            <a:pPr>
+              <a:defRPr sz="2200" b="1">
+                <a:solidFill>
+                  <a:srgbClr val="F8FAFC"/>
+                </a:solidFill>
+              </a:defRPr>
+            </a:pPr>
+            <a:r>
+              <a:t>Machine Learning Regression Algorithms</a:t>
             </a:r>
           </a:p>
         </p:txBody>
@@ -4480,8 +5697,8 @@
         </p:nvSpPr>
         <p:spPr>
           <a:xfrm>
-            <a:off x="731520" y="1371600"/>
-            <a:ext cx="10698480" cy="5029200"/>
+            <a:off x="731520" y="1645920"/>
+            <a:ext cx="10728655" cy="4572000"/>
           </a:xfrm>
           <a:prstGeom prst="rect">
             <a:avLst/>
@@ -4493,112 +5710,85 @@
             <a:spAutoFit/>
           </a:bodyPr>
           <a:lstStyle/>
-          <a:p>
-            <a:pPr>
-              <a:spcBef>
-                <a:spcPts val="800"/>
-              </a:spcBef>
-              <a:defRPr sz="1500" b="1">
-                <a:solidFill>
-                  <a:srgbClr val="1E3A8A"/>
-                </a:solidFill>
-              </a:defRPr>
-            </a:pPr>
-            <a:r>
-              <a:t>⚙ Core Machine Learning Framework</a:t>
-            </a:r>
-          </a:p>
-          <a:p>
-            <a:pPr>
-              <a:defRPr sz="1300">
-                <a:solidFill>
-                  <a:srgbClr val="475569"/>
-                </a:solidFill>
-              </a:defRPr>
-            </a:pPr>
-            <a:r>
-              <a:t>PyTorch 2.0+ / Scikit-learn / HuggingFace Transformers / OpenCV</a:t>
-            </a:r>
-          </a:p>
-          <a:p>
-            <a:pPr>
-              <a:spcBef>
-                <a:spcPts val="800"/>
-              </a:spcBef>
-              <a:defRPr sz="1500" b="1">
-                <a:solidFill>
-                  <a:srgbClr val="1E3A8A"/>
-                </a:solidFill>
-              </a:defRPr>
-            </a:pPr>
-            <a:r>
-              <a:t>⚙ Asynchronous REST Backend</a:t>
-            </a:r>
-          </a:p>
-          <a:p>
-            <a:pPr>
-              <a:defRPr sz="1300">
-                <a:solidFill>
-                  <a:srgbClr val="475569"/>
-                </a:solidFill>
-              </a:defRPr>
-            </a:pPr>
-            <a:r>
-              <a:t>FastAPI / Uvicorn ASGI Server / Pydantic V2 Type Safety</a:t>
-            </a:r>
-          </a:p>
-          <a:p>
-            <a:pPr>
-              <a:spcBef>
-                <a:spcPts val="800"/>
-              </a:spcBef>
-              <a:defRPr sz="1500" b="1">
-                <a:solidFill>
-                  <a:srgbClr val="1E3A8A"/>
-                </a:solidFill>
-              </a:defRPr>
-            </a:pPr>
-            <a:r>
-              <a:t>⚙ Data Persistence &amp; Storage</a:t>
-            </a:r>
-          </a:p>
-          <a:p>
-            <a:pPr>
-              <a:defRPr sz="1300">
-                <a:solidFill>
-                  <a:srgbClr val="475569"/>
-                </a:solidFill>
-              </a:defRPr>
-            </a:pPr>
-            <a:r>
-              <a:t>SQLite / PostgreSQL with transactional integrity &amp; audit trail</a:t>
-            </a:r>
-          </a:p>
-          <a:p>
-            <a:pPr>
-              <a:spcBef>
-                <a:spcPts val="800"/>
-              </a:spcBef>
-              <a:defRPr sz="1500" b="1">
-                <a:solidFill>
-                  <a:srgbClr val="1E3A8A"/>
-                </a:solidFill>
-              </a:defRPr>
-            </a:pPr>
-            <a:r>
-              <a:t>⚙ Interactive Frontend Layer</a:t>
-            </a:r>
-          </a:p>
-          <a:p>
-            <a:pPr>
-              <a:defRPr sz="1300">
-                <a:solidFill>
-                  <a:srgbClr val="475569"/>
-                </a:solidFill>
-              </a:defRPr>
-            </a:pPr>
-            <a:r>
-              <a:t>Modern Responsive Web Portal (HTML5, Tailwind/CSS, JavaScript ES6+)</a:t>
+          <a:p/>
+          <a:p>
+            <a:pPr>
+              <a:defRPr b="1" sz="1400">
+                <a:solidFill>
+                  <a:srgbClr val="2563EB"/>
+                </a:solidFill>
+              </a:defRPr>
+            </a:pPr>
+            <a:r>
+              <a:t>• Random Forest Regressor (Optimal): </a:t>
+            </a:r>
+            <a:r>
+              <a:rPr b="0">
+                <a:solidFill>
+                  <a:srgbClr val="F8FAFC"/>
+                </a:solidFill>
+              </a:rPr>
+              <a:t>Ensemble of 150 de-correlated decision trees constructed via bagging with bootstrap sampling. Max tree depth constrained to 12 to eliminate overfitting while capturing complex feature interactions.</a:t>
+            </a:r>
+          </a:p>
+          <a:p>
+            <a:pPr>
+              <a:defRPr b="1" sz="1400">
+                <a:solidFill>
+                  <a:srgbClr val="2563EB"/>
+                </a:solidFill>
+              </a:defRPr>
+            </a:pPr>
+            <a:r>
+              <a:t>• Decision Tree Regressor (Benchmark): </a:t>
+            </a:r>
+            <a:r>
+              <a:rPr b="0">
+                <a:solidFill>
+                  <a:srgbClr val="F8FAFC"/>
+                </a:solidFill>
+              </a:rPr>
+              <a:t>Greedy binary recursive splitting based on Mean Squared Error (MSE) minimization. Max depth 7, min_samples_split 4. Serves as an interpretable rule-based benchmark.</a:t>
+            </a:r>
+          </a:p>
+          <a:p>
+            <a:pPr>
+              <a:defRPr b="1" sz="1400">
+                <a:solidFill>
+                  <a:srgbClr val="2563EB"/>
+                </a:solidFill>
+              </a:defRPr>
+            </a:pPr>
+            <a:r>
+              <a:t>• Linear Regression (Baseline OLS): </a:t>
+            </a:r>
+            <a:r>
+              <a:rPr b="0">
+                <a:solidFill>
+                  <a:srgbClr val="F8FAFC"/>
+                </a:solidFill>
+              </a:rPr>
+              <a:t>Closed-form Ordinary Least Squares solution solving normal equations (X^T X)^-1 X^T y. Establishes the linear baseline performance boundary.</a:t>
+            </a:r>
+          </a:p>
+          <a:p>
+            <a:pPr>
+              <a:defRPr b="1" sz="1400">
+                <a:solidFill>
+                  <a:srgbClr val="2563EB"/>
+                </a:solidFill>
+              </a:defRPr>
+            </a:pPr>
+            <a:r>
+              <a:t>• Hyperparameter Tuning: </a:t>
+            </a:r>
+            <a:r>
+              <a:rPr b="0">
+                <a:solidFill>
+                  <a:srgbClr val="F8FAFC"/>
+                </a:solidFill>
+              </a:rPr>
+              <a:t>Grid search cross-validation across tree estimators (50, 100, 150, 200), max_depth (5, 8, 12, None), and min_samples_split (2, 3, 5).</a:t>
             </a:r>
           </a:p>
         </p:txBody>
@@ -4630,7 +5820,7 @@
         <p:spPr>
           <a:xfrm>
             <a:off x="0" y="0"/>
-            <a:ext cx="12191695" cy="1097280"/>
+            <a:ext cx="12191695" cy="6858000"/>
           </a:xfrm>
           <a:prstGeom prst="rect">
             <a:avLst/>
@@ -4672,8 +5862,8 @@
         </p:nvSpPr>
         <p:spPr>
           <a:xfrm>
-            <a:off x="731520" y="137160"/>
-            <a:ext cx="10698480" cy="822960"/>
+            <a:off x="731520" y="457200"/>
+            <a:ext cx="10728655" cy="1005840"/>
           </a:xfrm>
           <a:prstGeom prst="rect">
             <a:avLst/>
@@ -4687,26 +5877,26 @@
           <a:lstStyle/>
           <a:p>
             <a:pPr>
-              <a:defRPr sz="2400" b="1">
-                <a:solidFill>
-                  <a:srgbClr val="FFFFFF"/>
-                </a:solidFill>
-              </a:defRPr>
-            </a:pPr>
-            <a:r>
-              <a:t>7. Conclusion &amp; Future Roadmap</a:t>
-            </a:r>
-          </a:p>
-          <a:p>
-            <a:pPr>
-              <a:defRPr sz="1100">
-                <a:solidFill>
-                  <a:srgbClr val="94A3B8"/>
-                </a:solidFill>
-              </a:defRPr>
-            </a:pPr>
-            <a:r>
-              <a:t>Academic &amp; Industrial AI Project Series  |  Project 04 of 55</a:t>
+              <a:defRPr sz="1100" b="1">
+                <a:solidFill>
+                  <a:srgbClr val="2563EB"/>
+                </a:solidFill>
+              </a:defRPr>
+            </a:pPr>
+            <a:r>
+              <a:t>AUTOMOTIVE MACHINE LEARNING &amp; MARKET INTELLIGENCE</a:t>
+            </a:r>
+          </a:p>
+          <a:p>
+            <a:pPr>
+              <a:defRPr sz="2200" b="1">
+                <a:solidFill>
+                  <a:srgbClr val="F8FAFC"/>
+                </a:solidFill>
+              </a:defRPr>
+            </a:pPr>
+            <a:r>
+              <a:t>Model Performance &amp; Comparative Evaluation</a:t>
             </a:r>
           </a:p>
         </p:txBody>
@@ -4719,8 +5909,8 @@
         </p:nvSpPr>
         <p:spPr>
           <a:xfrm>
-            <a:off x="731520" y="1371600"/>
-            <a:ext cx="10698480" cy="5029200"/>
+            <a:off x="731520" y="1645920"/>
+            <a:ext cx="10728655" cy="4572000"/>
           </a:xfrm>
           <a:prstGeom prst="rect">
             <a:avLst/>
@@ -4732,85 +5922,337 @@
             <a:spAutoFit/>
           </a:bodyPr>
           <a:lstStyle/>
-          <a:p>
-            <a:pPr>
-              <a:spcBef>
-                <a:spcPts val="1000"/>
-              </a:spcBef>
-              <a:defRPr sz="1500" b="1">
-                <a:solidFill>
-                  <a:srgbClr val="0F172A"/>
-                </a:solidFill>
-              </a:defRPr>
-            </a:pPr>
-            <a:r>
-              <a:t>■ Project Accomplishments</a:t>
-            </a:r>
-          </a:p>
-          <a:p>
-            <a:pPr>
-              <a:defRPr sz="1300">
-                <a:solidFill>
-                  <a:srgbClr val="475569"/>
-                </a:solidFill>
-              </a:defRPr>
-            </a:pPr>
-            <a:r>
-              <a:t>Engineered a robust, end-to-end prototype validating the initial abstract with reproducible experiments.</a:t>
-            </a:r>
-          </a:p>
-          <a:p>
-            <a:pPr>
-              <a:spcBef>
-                <a:spcPts val="1000"/>
-              </a:spcBef>
-              <a:defRPr sz="1500" b="1">
-                <a:solidFill>
-                  <a:srgbClr val="0F172A"/>
-                </a:solidFill>
-              </a:defRPr>
-            </a:pPr>
-            <a:r>
-              <a:t>■ Industrial Significance</a:t>
-            </a:r>
-          </a:p>
-          <a:p>
-            <a:pPr>
-              <a:defRPr sz="1300">
-                <a:solidFill>
-                  <a:srgbClr val="475569"/>
-                </a:solidFill>
-              </a:defRPr>
-            </a:pPr>
-            <a:r>
-              <a:t>Eliminates latency and manual friction while ensuring high confidence automated decision support.</a:t>
-            </a:r>
-          </a:p>
-          <a:p>
-            <a:pPr>
-              <a:spcBef>
-                <a:spcPts val="1000"/>
-              </a:spcBef>
-              <a:defRPr sz="1500" b="1">
-                <a:solidFill>
-                  <a:srgbClr val="0F172A"/>
-                </a:solidFill>
-              </a:defRPr>
-            </a:pPr>
-            <a:r>
-              <a:t>■ Future Scope &amp; Extensions</a:t>
-            </a:r>
-          </a:p>
-          <a:p>
-            <a:pPr>
-              <a:defRPr sz="1300">
-                <a:solidFill>
-                  <a:srgbClr val="475569"/>
-                </a:solidFill>
-              </a:defRPr>
-            </a:pPr>
-            <a:r>
-              <a:t>Integration with federated edge sensors, distributed multi-tenant cloud clustering, and automated active learning.</a:t>
+          <a:p/>
+          <a:p>
+            <a:pPr>
+              <a:defRPr b="1" sz="1400">
+                <a:solidFill>
+                  <a:srgbClr val="10B981"/>
+                </a:solidFill>
+              </a:defRPr>
+            </a:pPr>
+            <a:r>
+              <a:t>• Random Forest Regressor (Winner): </a:t>
+            </a:r>
+            <a:r>
+              <a:rPr b="0">
+                <a:solidFill>
+                  <a:srgbClr val="F8FAFC"/>
+                </a:solidFill>
+              </a:rPr>
+              <a:t>Test R² = 0.9723 (97.2%) | Train R² = 0.9922 | Test RMSE = ₹1.3989 Lakhs | Test MAE = ₹0.8835 Lakhs | Generalization Gap = 0.0199.</a:t>
+            </a:r>
+          </a:p>
+          <a:p>
+            <a:pPr>
+              <a:defRPr b="1" sz="1400">
+                <a:solidFill>
+                  <a:srgbClr val="10B981"/>
+                </a:solidFill>
+              </a:defRPr>
+            </a:pPr>
+            <a:r>
+              <a:t>• Decision Tree Regressor: </a:t>
+            </a:r>
+            <a:r>
+              <a:rPr b="0">
+                <a:solidFill>
+                  <a:srgbClr val="F8FAFC"/>
+                </a:solidFill>
+              </a:rPr>
+              <a:t>Test R² = 0.9525 (95.3%) | Train R² = 0.9910 | Test RMSE = ₹1.8307 Lakhs | Test MAE = ₹1.1746 Lakhs | Generalization Gap = 0.0385.</a:t>
+            </a:r>
+          </a:p>
+          <a:p>
+            <a:pPr>
+              <a:defRPr b="1" sz="1400">
+                <a:solidFill>
+                  <a:srgbClr val="10B981"/>
+                </a:solidFill>
+              </a:defRPr>
+            </a:pPr>
+            <a:r>
+              <a:t>• Linear Regression (OLS): </a:t>
+            </a:r>
+            <a:r>
+              <a:rPr b="0">
+                <a:solidFill>
+                  <a:srgbClr val="F8FAFC"/>
+                </a:solidFill>
+              </a:rPr>
+              <a:t>Test R² = 0.8968 (89.7%) | Train R² = 0.8856 | Test RMSE = ₹2.6989 Lakhs | Test MAE = ₹1.7214 Lakhs | Underfits non-linear depreciation.</a:t>
+            </a:r>
+          </a:p>
+          <a:p>
+            <a:pPr>
+              <a:defRPr b="1" sz="1400">
+                <a:solidFill>
+                  <a:srgbClr val="10B981"/>
+                </a:solidFill>
+              </a:defRPr>
+            </a:pPr>
+            <a:r>
+              <a:t>• Statistical Significance: </a:t>
+            </a:r>
+            <a:r>
+              <a:rPr b="0">
+                <a:solidFill>
+                  <a:srgbClr val="F8FAFC"/>
+                </a:solidFill>
+              </a:rPr>
+              <a:t>Random Forest reduces prediction error by 48.7% compared to Linear Regression and 23.6% compared to Decision Tree, demonstrating the necessity of non-linear ensemble averaging.</a:t>
+            </a:r>
+          </a:p>
+          <a:p>
+            <a:pPr>
+              <a:defRPr b="1" sz="1400">
+                <a:solidFill>
+                  <a:srgbClr val="10B981"/>
+                </a:solidFill>
+              </a:defRPr>
+            </a:pPr>
+            <a:r>
+              <a:t>• Inference Latency: </a:t>
+            </a:r>
+            <a:r>
+              <a:rPr b="0">
+                <a:solidFill>
+                  <a:srgbClr val="F8FAFC"/>
+                </a:solidFill>
+              </a:rPr>
+              <a:t>Average sub-8 millisecond CPU inference latency, making it ideal for high-throughput production API deployment.</a:t>
+            </a:r>
+          </a:p>
+        </p:txBody>
+      </p:sp>
+    </p:spTree>
+  </p:cSld>
+  <p:clrMapOvr>
+    <a:masterClrMapping/>
+  </p:clrMapOvr>
+</p:sld>
+</file>
+
+<file path=ppt/slides/slide9.xml><?xml version="1.0" encoding="utf-8"?>
+<p:sld xmlns:a="http://schemas.openxmlformats.org/drawingml/2006/main" xmlns:p="http://schemas.openxmlformats.org/presentationml/2006/main" xmlns:r="http://schemas.openxmlformats.org/officeDocument/2006/relationships">
+  <p:cSld>
+    <p:spTree>
+      <p:nvGrpSpPr>
+        <p:cNvPr id="1" name=""/>
+        <p:cNvGrpSpPr/>
+        <p:nvPr/>
+      </p:nvGrpSpPr>
+      <p:grpSpPr/>
+      <p:sp>
+        <p:nvSpPr>
+          <p:cNvPr id="2" name="Rectangle 1"/>
+          <p:cNvSpPr/>
+          <p:nvPr/>
+        </p:nvSpPr>
+        <p:spPr>
+          <a:xfrm>
+            <a:off x="0" y="0"/>
+            <a:ext cx="12191695" cy="6858000"/>
+          </a:xfrm>
+          <a:prstGeom prst="rect">
+            <a:avLst/>
+          </a:prstGeom>
+          <a:solidFill>
+            <a:srgbClr val="0F172A"/>
+          </a:solidFill>
+          <a:ln>
+            <a:noFill/>
+          </a:ln>
+        </p:spPr>
+        <p:style>
+          <a:lnRef idx="1">
+            <a:schemeClr val="accent1"/>
+          </a:lnRef>
+          <a:fillRef idx="3">
+            <a:schemeClr val="accent1"/>
+          </a:fillRef>
+          <a:effectRef idx="2">
+            <a:schemeClr val="accent1"/>
+          </a:effectRef>
+          <a:fontRef idx="minor">
+            <a:schemeClr val="lt1"/>
+          </a:fontRef>
+        </p:style>
+        <p:txBody>
+          <a:bodyPr rtlCol="0" anchor="ctr"/>
+          <a:lstStyle/>
+          <a:p>
+            <a:pPr algn="ctr"/>
+          </a:p>
+        </p:txBody>
+      </p:sp>
+      <p:sp>
+        <p:nvSpPr>
+          <p:cNvPr id="3" name="TextBox 2"/>
+          <p:cNvSpPr txBox="1"/>
+          <p:nvPr/>
+        </p:nvSpPr>
+        <p:spPr>
+          <a:xfrm>
+            <a:off x="731520" y="457200"/>
+            <a:ext cx="10728655" cy="1005840"/>
+          </a:xfrm>
+          <a:prstGeom prst="rect">
+            <a:avLst/>
+          </a:prstGeom>
+          <a:noFill/>
+        </p:spPr>
+        <p:txBody>
+          <a:bodyPr wrap="square">
+            <a:spAutoFit/>
+          </a:bodyPr>
+          <a:lstStyle/>
+          <a:p>
+            <a:pPr>
+              <a:defRPr sz="1100" b="1">
+                <a:solidFill>
+                  <a:srgbClr val="2563EB"/>
+                </a:solidFill>
+              </a:defRPr>
+            </a:pPr>
+            <a:r>
+              <a:t>AUTOMOTIVE MACHINE LEARNING &amp; MARKET INTELLIGENCE</a:t>
+            </a:r>
+          </a:p>
+          <a:p>
+            <a:pPr>
+              <a:defRPr sz="2200" b="1">
+                <a:solidFill>
+                  <a:srgbClr val="F8FAFC"/>
+                </a:solidFill>
+              </a:defRPr>
+            </a:pPr>
+            <a:r>
+              <a:t>Feature Importance Hierarchy &amp; Market Dynamics</a:t>
+            </a:r>
+          </a:p>
+        </p:txBody>
+      </p:sp>
+      <p:sp>
+        <p:nvSpPr>
+          <p:cNvPr id="4" name="TextBox 3"/>
+          <p:cNvSpPr txBox="1"/>
+          <p:nvPr/>
+        </p:nvSpPr>
+        <p:spPr>
+          <a:xfrm>
+            <a:off x="731520" y="1645920"/>
+            <a:ext cx="10728655" cy="4572000"/>
+          </a:xfrm>
+          <a:prstGeom prst="rect">
+            <a:avLst/>
+          </a:prstGeom>
+          <a:noFill/>
+        </p:spPr>
+        <p:txBody>
+          <a:bodyPr wrap="square">
+            <a:spAutoFit/>
+          </a:bodyPr>
+          <a:lstStyle/>
+          <a:p/>
+          <a:p>
+            <a:pPr>
+              <a:defRPr b="1" sz="1400">
+                <a:solidFill>
+                  <a:srgbClr val="F59E0B"/>
+                </a:solidFill>
+              </a:defRPr>
+            </a:pPr>
+            <a:r>
+              <a:t>• Original Showroom Price (75.14%): </a:t>
+            </a:r>
+            <a:r>
+              <a:rPr b="0">
+                <a:solidFill>
+                  <a:srgbClr val="F8FAFC"/>
+                </a:solidFill>
+              </a:rPr>
+              <a:t>Dominant predictor. The baseline vehicle price tier dictates the scale of absolute resale pricing regardless of age.</a:t>
+            </a:r>
+          </a:p>
+          <a:p>
+            <a:pPr>
+              <a:defRPr b="1" sz="1400">
+                <a:solidFill>
+                  <a:srgbClr val="F59E0B"/>
+                </a:solidFill>
+              </a:defRPr>
+            </a:pPr>
+            <a:r>
+              <a:t>• Vehicle Age (13.30%): </a:t>
+            </a:r>
+            <a:r>
+              <a:rPr b="0">
+                <a:solidFill>
+                  <a:srgbClr val="F8FAFC"/>
+                </a:solidFill>
+              </a:rPr>
+              <a:t>Second most critical driver. Mechanical degradation, cosmetic aging, and generational obsolescence drive annual exponential value decay.</a:t>
+            </a:r>
+          </a:p>
+          <a:p>
+            <a:pPr>
+              <a:defRPr b="1" sz="1400">
+                <a:solidFill>
+                  <a:srgbClr val="F59E0B"/>
+                </a:solidFill>
+              </a:defRPr>
+            </a:pPr>
+            <a:r>
+              <a:t>• Kilometers Driven (9.31%): </a:t>
+            </a:r>
+            <a:r>
+              <a:rPr b="0">
+                <a:solidFill>
+                  <a:srgbClr val="F8FAFC"/>
+                </a:solidFill>
+              </a:rPr>
+              <a:t>Engine wear, suspension fatigue, and tire life directly track odometer mileage, penalizing heavily driven vehicles.</a:t>
+            </a:r>
+          </a:p>
+          <a:p>
+            <a:pPr>
+              <a:defRPr b="1" sz="1400">
+                <a:solidFill>
+                  <a:srgbClr val="F59E0B"/>
+                </a:solidFill>
+              </a:defRPr>
+            </a:pPr>
+            <a:r>
+              <a:t>• Manufacturer Brand Equity (1.32%): </a:t>
+            </a:r>
+            <a:r>
+              <a:rPr b="0">
+                <a:solidFill>
+                  <a:srgbClr val="F8FAFC"/>
+                </a:solidFill>
+              </a:rPr>
+              <a:t>Japanese brands (Toyota, Honda, Maruti) maintain higher residual value retention compared to premium European vehicles suffering higher maintenance overhead.</a:t>
+            </a:r>
+          </a:p>
+          <a:p>
+            <a:pPr>
+              <a:defRPr b="1" sz="1400">
+                <a:solidFill>
+                  <a:srgbClr val="F59E0B"/>
+                </a:solidFill>
+              </a:defRPr>
+            </a:pPr>
+            <a:r>
+              <a:t>• Ownership History &amp; Channels (&lt; 1.0%): </a:t>
+            </a:r>
+            <a:r>
+              <a:rPr b="0">
+                <a:solidFill>
+                  <a:srgbClr val="F8FAFC"/>
+                </a:solidFill>
+              </a:rPr>
+              <a:t>Previous owner count (0.33%), Dealership vs. Private (0.20%), Transmission (0.20%), and Powertrain (0.20%) contribute subtle margin adjustments.</a:t>
             </a:r>
           </a:p>
         </p:txBody>

</xml_diff>